<commit_message>
Add PPTX ignore and update PPTX file
Appended two '*.pptx' entries to .gitignore (duplicate lines were added). Replaced/updated a binary .pptx file (filename contains non-ASCII/Chinese characters). The .gitignore change aims to exclude PPTX files from commits; the duplicate entries appear accidental.
</commit_message>
<xml_diff>
--- a/第二章/2.5 传输层技术介绍/传输层_改进版.pptx
+++ b/第二章/2.5 传输层技术介绍/传输层_改进版.pptx
@@ -5,53 +5,53 @@
     <p:sldMasterId id="2147483648" r:id="rId1"/>
   </p:sldMasterIdLst>
   <p:sldIdLst>
-    <p:sldId id="256" r:id="rId7"/>
-    <p:sldId id="257" r:id="rId8"/>
-    <p:sldId id="258" r:id="rId9"/>
-    <p:sldId id="259" r:id="rId10"/>
-    <p:sldId id="260" r:id="rId11"/>
-    <p:sldId id="261" r:id="rId12"/>
-    <p:sldId id="262" r:id="rId13"/>
-    <p:sldId id="263" r:id="rId14"/>
-    <p:sldId id="264" r:id="rId15"/>
-    <p:sldId id="265" r:id="rId16"/>
-    <p:sldId id="266" r:id="rId17"/>
-    <p:sldId id="267" r:id="rId18"/>
-    <p:sldId id="268" r:id="rId19"/>
-    <p:sldId id="269" r:id="rId20"/>
-    <p:sldId id="270" r:id="rId21"/>
-    <p:sldId id="271" r:id="rId22"/>
-    <p:sldId id="272" r:id="rId23"/>
-    <p:sldId id="273" r:id="rId24"/>
-    <p:sldId id="274" r:id="rId25"/>
-    <p:sldId id="275" r:id="rId26"/>
-    <p:sldId id="276" r:id="rId27"/>
-    <p:sldId id="277" r:id="rId28"/>
-    <p:sldId id="278" r:id="rId29"/>
-    <p:sldId id="279" r:id="rId30"/>
-    <p:sldId id="280" r:id="rId31"/>
-    <p:sldId id="281" r:id="rId32"/>
-    <p:sldId id="282" r:id="rId33"/>
-    <p:sldId id="283" r:id="rId34"/>
-    <p:sldId id="284" r:id="rId35"/>
-    <p:sldId id="285" r:id="rId36"/>
-    <p:sldId id="286" r:id="rId37"/>
-    <p:sldId id="287" r:id="rId38"/>
-    <p:sldId id="288" r:id="rId39"/>
-    <p:sldId id="289" r:id="rId40"/>
-    <p:sldId id="290" r:id="rId41"/>
-    <p:sldId id="291" r:id="rId42"/>
-    <p:sldId id="292" r:id="rId43"/>
-    <p:sldId id="293" r:id="rId44"/>
-    <p:sldId id="294" r:id="rId45"/>
-    <p:sldId id="295" r:id="rId46"/>
-    <p:sldId id="296" r:id="rId47"/>
-    <p:sldId id="297" r:id="rId48"/>
-    <p:sldId id="298" r:id="rId49"/>
-    <p:sldId id="299" r:id="rId50"/>
-    <p:sldId id="300" r:id="rId51"/>
-    <p:sldId id="301" r:id="rId52"/>
-    <p:sldId id="302" r:id="rId53"/>
+    <p:sldId id="256" r:id="rId2"/>
+    <p:sldId id="257" r:id="rId3"/>
+    <p:sldId id="258" r:id="rId4"/>
+    <p:sldId id="259" r:id="rId5"/>
+    <p:sldId id="260" r:id="rId6"/>
+    <p:sldId id="261" r:id="rId7"/>
+    <p:sldId id="262" r:id="rId8"/>
+    <p:sldId id="263" r:id="rId9"/>
+    <p:sldId id="264" r:id="rId10"/>
+    <p:sldId id="265" r:id="rId11"/>
+    <p:sldId id="266" r:id="rId12"/>
+    <p:sldId id="267" r:id="rId13"/>
+    <p:sldId id="268" r:id="rId14"/>
+    <p:sldId id="269" r:id="rId15"/>
+    <p:sldId id="270" r:id="rId16"/>
+    <p:sldId id="271" r:id="rId17"/>
+    <p:sldId id="272" r:id="rId18"/>
+    <p:sldId id="273" r:id="rId19"/>
+    <p:sldId id="274" r:id="rId20"/>
+    <p:sldId id="275" r:id="rId21"/>
+    <p:sldId id="276" r:id="rId22"/>
+    <p:sldId id="277" r:id="rId23"/>
+    <p:sldId id="278" r:id="rId24"/>
+    <p:sldId id="279" r:id="rId25"/>
+    <p:sldId id="280" r:id="rId26"/>
+    <p:sldId id="281" r:id="rId27"/>
+    <p:sldId id="282" r:id="rId28"/>
+    <p:sldId id="283" r:id="rId29"/>
+    <p:sldId id="284" r:id="rId30"/>
+    <p:sldId id="285" r:id="rId31"/>
+    <p:sldId id="286" r:id="rId32"/>
+    <p:sldId id="287" r:id="rId33"/>
+    <p:sldId id="288" r:id="rId34"/>
+    <p:sldId id="289" r:id="rId35"/>
+    <p:sldId id="290" r:id="rId36"/>
+    <p:sldId id="291" r:id="rId37"/>
+    <p:sldId id="292" r:id="rId38"/>
+    <p:sldId id="293" r:id="rId39"/>
+    <p:sldId id="294" r:id="rId40"/>
+    <p:sldId id="295" r:id="rId41"/>
+    <p:sldId id="296" r:id="rId42"/>
+    <p:sldId id="297" r:id="rId43"/>
+    <p:sldId id="298" r:id="rId44"/>
+    <p:sldId id="299" r:id="rId45"/>
+    <p:sldId id="300" r:id="rId46"/>
+    <p:sldId id="301" r:id="rId47"/>
+    <p:sldId id="302" r:id="rId48"/>
   </p:sldIdLst>
   <p:sldSz cx="9144000" cy="6858000" type="screen4x3"/>
   <p:notesSz cx="6858000" cy="9144000"/>
@@ -150,6 +150,22 @@
       </a:defRPr>
     </a:lvl9pPr>
   </p:defaultTextStyle>
+  <p:extLst>
+    <p:ext uri="{EFAFB233-063F-42B5-8137-9DF3F51BA10A}">
+      <p15:sldGuideLst xmlns:p15="http://schemas.microsoft.com/office/powerpoint/2012/main">
+        <p15:guide id="1" orient="horz" pos="2160">
+          <p15:clr>
+            <a:srgbClr val="A4A3A4"/>
+          </p15:clr>
+        </p15:guide>
+        <p15:guide id="2" pos="2880">
+          <p15:clr>
+            <a:srgbClr val="A4A3A4"/>
+          </p15:clr>
+        </p15:guide>
+      </p15:sldGuideLst>
+    </p:ext>
+  </p:extLst>
 </p:presentation>
 </file>
 
@@ -191,10 +207,9 @@
           <a:lstStyle/>
           <a:p>
             <a:r>
-              <a:rPr lang="en-US" smtClean="0"/>
+              <a:rPr lang="en-US"/>
               <a:t>Click to edit Master title style</a:t>
             </a:r>
-            <a:endParaRPr lang="en-US"/>
           </a:p>
         </p:txBody>
       </p:sp>
@@ -310,10 +325,9 @@
           </a:lstStyle>
           <a:p>
             <a:r>
-              <a:rPr lang="en-US" smtClean="0"/>
+              <a:rPr lang="en-US"/>
               <a:t>Click to edit Master subtitle style</a:t>
             </a:r>
-            <a:endParaRPr lang="en-US"/>
           </a:p>
         </p:txBody>
       </p:sp>
@@ -334,7 +348,7 @@
           <a:p>
             <a:fld id="{5BCAD085-E8A6-8845-BD4E-CB4CCA059FC4}" type="datetimeFigureOut">
               <a:rPr lang="en-US" smtClean="0"/>
-              <a:t>1/27/13</a:t>
+              <a:t>3/20/2026</a:t>
             </a:fld>
             <a:endParaRPr lang="en-US"/>
           </a:p>
@@ -428,10 +442,9 @@
           <a:lstStyle/>
           <a:p>
             <a:r>
-              <a:rPr lang="en-US" smtClean="0"/>
+              <a:rPr lang="en-US"/>
               <a:t>Click to edit Master title style</a:t>
             </a:r>
-            <a:endParaRPr lang="en-US"/>
           </a:p>
         </p:txBody>
       </p:sp>
@@ -452,38 +465,37 @@
           <a:p>
             <a:pPr lvl="0"/>
             <a:r>
-              <a:rPr lang="en-US" smtClean="0"/>
+              <a:rPr lang="en-US"/>
               <a:t>Click to edit Master text styles</a:t>
             </a:r>
           </a:p>
           <a:p>
             <a:pPr lvl="1"/>
             <a:r>
-              <a:rPr lang="en-US" smtClean="0"/>
+              <a:rPr lang="en-US"/>
               <a:t>Second level</a:t>
             </a:r>
           </a:p>
           <a:p>
             <a:pPr lvl="2"/>
             <a:r>
-              <a:rPr lang="en-US" smtClean="0"/>
+              <a:rPr lang="en-US"/>
               <a:t>Third level</a:t>
             </a:r>
           </a:p>
           <a:p>
             <a:pPr lvl="3"/>
             <a:r>
-              <a:rPr lang="en-US" smtClean="0"/>
+              <a:rPr lang="en-US"/>
               <a:t>Fourth level</a:t>
             </a:r>
           </a:p>
           <a:p>
             <a:pPr lvl="4"/>
             <a:r>
-              <a:rPr lang="en-US" smtClean="0"/>
+              <a:rPr lang="en-US"/>
               <a:t>Fifth level</a:t>
             </a:r>
-            <a:endParaRPr lang="en-US"/>
           </a:p>
         </p:txBody>
       </p:sp>
@@ -504,7 +516,7 @@
           <a:p>
             <a:fld id="{5BCAD085-E8A6-8845-BD4E-CB4CCA059FC4}" type="datetimeFigureOut">
               <a:rPr lang="en-US" smtClean="0"/>
-              <a:t>1/27/13</a:t>
+              <a:t>3/20/2026</a:t>
             </a:fld>
             <a:endParaRPr lang="en-US"/>
           </a:p>
@@ -603,10 +615,9 @@
           <a:lstStyle/>
           <a:p>
             <a:r>
-              <a:rPr lang="en-US" smtClean="0"/>
+              <a:rPr lang="en-US"/>
               <a:t>Click to edit Master title style</a:t>
             </a:r>
-            <a:endParaRPr lang="en-US"/>
           </a:p>
         </p:txBody>
       </p:sp>
@@ -632,38 +643,37 @@
           <a:p>
             <a:pPr lvl="0"/>
             <a:r>
-              <a:rPr lang="en-US" smtClean="0"/>
+              <a:rPr lang="en-US"/>
               <a:t>Click to edit Master text styles</a:t>
             </a:r>
           </a:p>
           <a:p>
             <a:pPr lvl="1"/>
             <a:r>
-              <a:rPr lang="en-US" smtClean="0"/>
+              <a:rPr lang="en-US"/>
               <a:t>Second level</a:t>
             </a:r>
           </a:p>
           <a:p>
             <a:pPr lvl="2"/>
             <a:r>
-              <a:rPr lang="en-US" smtClean="0"/>
+              <a:rPr lang="en-US"/>
               <a:t>Third level</a:t>
             </a:r>
           </a:p>
           <a:p>
             <a:pPr lvl="3"/>
             <a:r>
-              <a:rPr lang="en-US" smtClean="0"/>
+              <a:rPr lang="en-US"/>
               <a:t>Fourth level</a:t>
             </a:r>
           </a:p>
           <a:p>
             <a:pPr lvl="4"/>
             <a:r>
-              <a:rPr lang="en-US" smtClean="0"/>
+              <a:rPr lang="en-US"/>
               <a:t>Fifth level</a:t>
             </a:r>
-            <a:endParaRPr lang="en-US"/>
           </a:p>
         </p:txBody>
       </p:sp>
@@ -684,7 +694,7 @@
           <a:p>
             <a:fld id="{5BCAD085-E8A6-8845-BD4E-CB4CCA059FC4}" type="datetimeFigureOut">
               <a:rPr lang="en-US" smtClean="0"/>
-              <a:t>1/27/13</a:t>
+              <a:t>3/20/2026</a:t>
             </a:fld>
             <a:endParaRPr lang="en-US"/>
           </a:p>
@@ -778,10 +788,9 @@
           <a:lstStyle/>
           <a:p>
             <a:r>
-              <a:rPr lang="en-US" smtClean="0"/>
+              <a:rPr lang="en-US"/>
               <a:t>Click to edit Master title style</a:t>
             </a:r>
-            <a:endParaRPr lang="en-US"/>
           </a:p>
         </p:txBody>
       </p:sp>
@@ -802,38 +811,37 @@
           <a:p>
             <a:pPr lvl="0"/>
             <a:r>
-              <a:rPr lang="en-US" smtClean="0"/>
+              <a:rPr lang="en-US"/>
               <a:t>Click to edit Master text styles</a:t>
             </a:r>
           </a:p>
           <a:p>
             <a:pPr lvl="1"/>
             <a:r>
-              <a:rPr lang="en-US" smtClean="0"/>
+              <a:rPr lang="en-US"/>
               <a:t>Second level</a:t>
             </a:r>
           </a:p>
           <a:p>
             <a:pPr lvl="2"/>
             <a:r>
-              <a:rPr lang="en-US" smtClean="0"/>
+              <a:rPr lang="en-US"/>
               <a:t>Third level</a:t>
             </a:r>
           </a:p>
           <a:p>
             <a:pPr lvl="3"/>
             <a:r>
-              <a:rPr lang="en-US" smtClean="0"/>
+              <a:rPr lang="en-US"/>
               <a:t>Fourth level</a:t>
             </a:r>
           </a:p>
           <a:p>
             <a:pPr lvl="4"/>
             <a:r>
-              <a:rPr lang="en-US" smtClean="0"/>
+              <a:rPr lang="en-US"/>
               <a:t>Fifth level</a:t>
             </a:r>
-            <a:endParaRPr lang="en-US"/>
           </a:p>
         </p:txBody>
       </p:sp>
@@ -854,7 +862,7 @@
           <a:p>
             <a:fld id="{5BCAD085-E8A6-8845-BD4E-CB4CCA059FC4}" type="datetimeFigureOut">
               <a:rPr lang="en-US" smtClean="0"/>
-              <a:t>1/27/13</a:t>
+              <a:t>3/20/2026</a:t>
             </a:fld>
             <a:endParaRPr lang="en-US"/>
           </a:p>
@@ -957,10 +965,9 @@
           </a:lstStyle>
           <a:p>
             <a:r>
-              <a:rPr lang="en-US" smtClean="0"/>
+              <a:rPr lang="en-US"/>
               <a:t>Click to edit Master title style</a:t>
             </a:r>
-            <a:endParaRPr lang="en-US"/>
           </a:p>
         </p:txBody>
       </p:sp>
@@ -1077,7 +1084,7 @@
           <a:p>
             <a:pPr lvl="0"/>
             <a:r>
-              <a:rPr lang="en-US" smtClean="0"/>
+              <a:rPr lang="en-US"/>
               <a:t>Click to edit Master text styles</a:t>
             </a:r>
           </a:p>
@@ -1100,7 +1107,7 @@
           <a:p>
             <a:fld id="{5BCAD085-E8A6-8845-BD4E-CB4CCA059FC4}" type="datetimeFigureOut">
               <a:rPr lang="en-US" smtClean="0"/>
-              <a:t>1/27/13</a:t>
+              <a:t>3/20/2026</a:t>
             </a:fld>
             <a:endParaRPr lang="en-US"/>
           </a:p>
@@ -1194,10 +1201,9 @@
           <a:lstStyle/>
           <a:p>
             <a:r>
-              <a:rPr lang="en-US" smtClean="0"/>
+              <a:rPr lang="en-US"/>
               <a:t>Click to edit Master title style</a:t>
             </a:r>
-            <a:endParaRPr lang="en-US"/>
           </a:p>
         </p:txBody>
       </p:sp>
@@ -1251,38 +1257,37 @@
           <a:p>
             <a:pPr lvl="0"/>
             <a:r>
-              <a:rPr lang="en-US" smtClean="0"/>
+              <a:rPr lang="en-US"/>
               <a:t>Click to edit Master text styles</a:t>
             </a:r>
           </a:p>
           <a:p>
             <a:pPr lvl="1"/>
             <a:r>
-              <a:rPr lang="en-US" smtClean="0"/>
+              <a:rPr lang="en-US"/>
               <a:t>Second level</a:t>
             </a:r>
           </a:p>
           <a:p>
             <a:pPr lvl="2"/>
             <a:r>
-              <a:rPr lang="en-US" smtClean="0"/>
+              <a:rPr lang="en-US"/>
               <a:t>Third level</a:t>
             </a:r>
           </a:p>
           <a:p>
             <a:pPr lvl="3"/>
             <a:r>
-              <a:rPr lang="en-US" smtClean="0"/>
+              <a:rPr lang="en-US"/>
               <a:t>Fourth level</a:t>
             </a:r>
           </a:p>
           <a:p>
             <a:pPr lvl="4"/>
             <a:r>
-              <a:rPr lang="en-US" smtClean="0"/>
+              <a:rPr lang="en-US"/>
               <a:t>Fifth level</a:t>
             </a:r>
-            <a:endParaRPr lang="en-US"/>
           </a:p>
         </p:txBody>
       </p:sp>
@@ -1336,38 +1341,37 @@
           <a:p>
             <a:pPr lvl="0"/>
             <a:r>
-              <a:rPr lang="en-US" smtClean="0"/>
+              <a:rPr lang="en-US"/>
               <a:t>Click to edit Master text styles</a:t>
             </a:r>
           </a:p>
           <a:p>
             <a:pPr lvl="1"/>
             <a:r>
-              <a:rPr lang="en-US" smtClean="0"/>
+              <a:rPr lang="en-US"/>
               <a:t>Second level</a:t>
             </a:r>
           </a:p>
           <a:p>
             <a:pPr lvl="2"/>
             <a:r>
-              <a:rPr lang="en-US" smtClean="0"/>
+              <a:rPr lang="en-US"/>
               <a:t>Third level</a:t>
             </a:r>
           </a:p>
           <a:p>
             <a:pPr lvl="3"/>
             <a:r>
-              <a:rPr lang="en-US" smtClean="0"/>
+              <a:rPr lang="en-US"/>
               <a:t>Fourth level</a:t>
             </a:r>
           </a:p>
           <a:p>
             <a:pPr lvl="4"/>
             <a:r>
-              <a:rPr lang="en-US" smtClean="0"/>
+              <a:rPr lang="en-US"/>
               <a:t>Fifth level</a:t>
             </a:r>
-            <a:endParaRPr lang="en-US"/>
           </a:p>
         </p:txBody>
       </p:sp>
@@ -1388,7 +1392,7 @@
           <a:p>
             <a:fld id="{5BCAD085-E8A6-8845-BD4E-CB4CCA059FC4}" type="datetimeFigureOut">
               <a:rPr lang="en-US" smtClean="0"/>
-              <a:t>1/27/13</a:t>
+              <a:t>3/20/2026</a:t>
             </a:fld>
             <a:endParaRPr lang="en-US"/>
           </a:p>
@@ -1486,10 +1490,9 @@
           </a:lstStyle>
           <a:p>
             <a:r>
-              <a:rPr lang="en-US" smtClean="0"/>
+              <a:rPr lang="en-US"/>
               <a:t>Click to edit Master title style</a:t>
             </a:r>
-            <a:endParaRPr lang="en-US"/>
           </a:p>
         </p:txBody>
       </p:sp>
@@ -1552,7 +1555,7 @@
           <a:p>
             <a:pPr lvl="0"/>
             <a:r>
-              <a:rPr lang="en-US" smtClean="0"/>
+              <a:rPr lang="en-US"/>
               <a:t>Click to edit Master text styles</a:t>
             </a:r>
           </a:p>
@@ -1608,38 +1611,37 @@
           <a:p>
             <a:pPr lvl="0"/>
             <a:r>
-              <a:rPr lang="en-US" smtClean="0"/>
+              <a:rPr lang="en-US"/>
               <a:t>Click to edit Master text styles</a:t>
             </a:r>
           </a:p>
           <a:p>
             <a:pPr lvl="1"/>
             <a:r>
-              <a:rPr lang="en-US" smtClean="0"/>
+              <a:rPr lang="en-US"/>
               <a:t>Second level</a:t>
             </a:r>
           </a:p>
           <a:p>
             <a:pPr lvl="2"/>
             <a:r>
-              <a:rPr lang="en-US" smtClean="0"/>
+              <a:rPr lang="en-US"/>
               <a:t>Third level</a:t>
             </a:r>
           </a:p>
           <a:p>
             <a:pPr lvl="3"/>
             <a:r>
-              <a:rPr lang="en-US" smtClean="0"/>
+              <a:rPr lang="en-US"/>
               <a:t>Fourth level</a:t>
             </a:r>
           </a:p>
           <a:p>
             <a:pPr lvl="4"/>
             <a:r>
-              <a:rPr lang="en-US" smtClean="0"/>
+              <a:rPr lang="en-US"/>
               <a:t>Fifth level</a:t>
             </a:r>
-            <a:endParaRPr lang="en-US"/>
           </a:p>
         </p:txBody>
       </p:sp>
@@ -1702,7 +1704,7 @@
           <a:p>
             <a:pPr lvl="0"/>
             <a:r>
-              <a:rPr lang="en-US" smtClean="0"/>
+              <a:rPr lang="en-US"/>
               <a:t>Click to edit Master text styles</a:t>
             </a:r>
           </a:p>
@@ -1758,38 +1760,37 @@
           <a:p>
             <a:pPr lvl="0"/>
             <a:r>
-              <a:rPr lang="en-US" smtClean="0"/>
+              <a:rPr lang="en-US"/>
               <a:t>Click to edit Master text styles</a:t>
             </a:r>
           </a:p>
           <a:p>
             <a:pPr lvl="1"/>
             <a:r>
-              <a:rPr lang="en-US" smtClean="0"/>
+              <a:rPr lang="en-US"/>
               <a:t>Second level</a:t>
             </a:r>
           </a:p>
           <a:p>
             <a:pPr lvl="2"/>
             <a:r>
-              <a:rPr lang="en-US" smtClean="0"/>
+              <a:rPr lang="en-US"/>
               <a:t>Third level</a:t>
             </a:r>
           </a:p>
           <a:p>
             <a:pPr lvl="3"/>
             <a:r>
-              <a:rPr lang="en-US" smtClean="0"/>
+              <a:rPr lang="en-US"/>
               <a:t>Fourth level</a:t>
             </a:r>
           </a:p>
           <a:p>
             <a:pPr lvl="4"/>
             <a:r>
-              <a:rPr lang="en-US" smtClean="0"/>
+              <a:rPr lang="en-US"/>
               <a:t>Fifth level</a:t>
             </a:r>
-            <a:endParaRPr lang="en-US"/>
           </a:p>
         </p:txBody>
       </p:sp>
@@ -1810,7 +1811,7 @@
           <a:p>
             <a:fld id="{5BCAD085-E8A6-8845-BD4E-CB4CCA059FC4}" type="datetimeFigureOut">
               <a:rPr lang="en-US" smtClean="0"/>
-              <a:t>1/27/13</a:t>
+              <a:t>3/20/2026</a:t>
             </a:fld>
             <a:endParaRPr lang="en-US"/>
           </a:p>
@@ -1904,10 +1905,9 @@
           <a:lstStyle/>
           <a:p>
             <a:r>
-              <a:rPr lang="en-US" smtClean="0"/>
+              <a:rPr lang="en-US"/>
               <a:t>Click to edit Master title style</a:t>
             </a:r>
-            <a:endParaRPr lang="en-US"/>
           </a:p>
         </p:txBody>
       </p:sp>
@@ -1928,7 +1928,7 @@
           <a:p>
             <a:fld id="{5BCAD085-E8A6-8845-BD4E-CB4CCA059FC4}" type="datetimeFigureOut">
               <a:rPr lang="en-US" smtClean="0"/>
-              <a:t>1/27/13</a:t>
+              <a:t>3/20/2026</a:t>
             </a:fld>
             <a:endParaRPr lang="en-US"/>
           </a:p>
@@ -2023,7 +2023,7 @@
           <a:p>
             <a:fld id="{5BCAD085-E8A6-8845-BD4E-CB4CCA059FC4}" type="datetimeFigureOut">
               <a:rPr lang="en-US" smtClean="0"/>
-              <a:t>1/27/13</a:t>
+              <a:t>3/20/2026</a:t>
             </a:fld>
             <a:endParaRPr lang="en-US"/>
           </a:p>
@@ -2126,10 +2126,9 @@
           </a:lstStyle>
           <a:p>
             <a:r>
-              <a:rPr lang="en-US" smtClean="0"/>
+              <a:rPr lang="en-US"/>
               <a:t>Click to edit Master title style</a:t>
             </a:r>
-            <a:endParaRPr lang="en-US"/>
           </a:p>
         </p:txBody>
       </p:sp>
@@ -2183,38 +2182,37 @@
           <a:p>
             <a:pPr lvl="0"/>
             <a:r>
-              <a:rPr lang="en-US" smtClean="0"/>
+              <a:rPr lang="en-US"/>
               <a:t>Click to edit Master text styles</a:t>
             </a:r>
           </a:p>
           <a:p>
             <a:pPr lvl="1"/>
             <a:r>
-              <a:rPr lang="en-US" smtClean="0"/>
+              <a:rPr lang="en-US"/>
               <a:t>Second level</a:t>
             </a:r>
           </a:p>
           <a:p>
             <a:pPr lvl="2"/>
             <a:r>
-              <a:rPr lang="en-US" smtClean="0"/>
+              <a:rPr lang="en-US"/>
               <a:t>Third level</a:t>
             </a:r>
           </a:p>
           <a:p>
             <a:pPr lvl="3"/>
             <a:r>
-              <a:rPr lang="en-US" smtClean="0"/>
+              <a:rPr lang="en-US"/>
               <a:t>Fourth level</a:t>
             </a:r>
           </a:p>
           <a:p>
             <a:pPr lvl="4"/>
             <a:r>
-              <a:rPr lang="en-US" smtClean="0"/>
+              <a:rPr lang="en-US"/>
               <a:t>Fifth level</a:t>
             </a:r>
-            <a:endParaRPr lang="en-US"/>
           </a:p>
         </p:txBody>
       </p:sp>
@@ -2277,7 +2275,7 @@
           <a:p>
             <a:pPr lvl="0"/>
             <a:r>
-              <a:rPr lang="en-US" smtClean="0"/>
+              <a:rPr lang="en-US"/>
               <a:t>Click to edit Master text styles</a:t>
             </a:r>
           </a:p>
@@ -2300,7 +2298,7 @@
           <a:p>
             <a:fld id="{5BCAD085-E8A6-8845-BD4E-CB4CCA059FC4}" type="datetimeFigureOut">
               <a:rPr lang="en-US" smtClean="0"/>
-              <a:t>1/27/13</a:t>
+              <a:t>3/20/2026</a:t>
             </a:fld>
             <a:endParaRPr lang="en-US"/>
           </a:p>
@@ -2403,10 +2401,9 @@
           </a:lstStyle>
           <a:p>
             <a:r>
-              <a:rPr lang="en-US" smtClean="0"/>
+              <a:rPr lang="en-US"/>
               <a:t>Click to edit Master title style</a:t>
             </a:r>
-            <a:endParaRPr lang="en-US"/>
           </a:p>
         </p:txBody>
       </p:sp>
@@ -2530,7 +2527,7 @@
           <a:p>
             <a:pPr lvl="0"/>
             <a:r>
-              <a:rPr lang="en-US" smtClean="0"/>
+              <a:rPr lang="en-US"/>
               <a:t>Click to edit Master text styles</a:t>
             </a:r>
           </a:p>
@@ -2553,7 +2550,7 @@
           <a:p>
             <a:fld id="{5BCAD085-E8A6-8845-BD4E-CB4CCA059FC4}" type="datetimeFigureOut">
               <a:rPr lang="en-US" smtClean="0"/>
-              <a:t>1/27/13</a:t>
+              <a:t>3/20/2026</a:t>
             </a:fld>
             <a:endParaRPr lang="en-US"/>
           </a:p>
@@ -2662,10 +2659,9 @@
           <a:lstStyle/>
           <a:p>
             <a:r>
-              <a:rPr lang="en-US" smtClean="0"/>
+              <a:rPr lang="en-US"/>
               <a:t>Click to edit Master title style</a:t>
             </a:r>
-            <a:endParaRPr lang="en-US"/>
           </a:p>
         </p:txBody>
       </p:sp>
@@ -2696,38 +2692,37 @@
           <a:p>
             <a:pPr lvl="0"/>
             <a:r>
-              <a:rPr lang="en-US" smtClean="0"/>
+              <a:rPr lang="en-US"/>
               <a:t>Click to edit Master text styles</a:t>
             </a:r>
           </a:p>
           <a:p>
             <a:pPr lvl="1"/>
             <a:r>
-              <a:rPr lang="en-US" smtClean="0"/>
+              <a:rPr lang="en-US"/>
               <a:t>Second level</a:t>
             </a:r>
           </a:p>
           <a:p>
             <a:pPr lvl="2"/>
             <a:r>
-              <a:rPr lang="en-US" smtClean="0"/>
+              <a:rPr lang="en-US"/>
               <a:t>Third level</a:t>
             </a:r>
           </a:p>
           <a:p>
             <a:pPr lvl="3"/>
             <a:r>
-              <a:rPr lang="en-US" smtClean="0"/>
+              <a:rPr lang="en-US"/>
               <a:t>Fourth level</a:t>
             </a:r>
           </a:p>
           <a:p>
             <a:pPr lvl="4"/>
             <a:r>
-              <a:rPr lang="en-US" smtClean="0"/>
+              <a:rPr lang="en-US"/>
               <a:t>Fifth level</a:t>
             </a:r>
-            <a:endParaRPr lang="en-US"/>
           </a:p>
         </p:txBody>
       </p:sp>
@@ -2766,7 +2761,7 @@
           <a:p>
             <a:fld id="{5BCAD085-E8A6-8845-BD4E-CB4CCA059FC4}" type="datetimeFigureOut">
               <a:rPr lang="en-US" smtClean="0"/>
-              <a:t>1/27/13</a:t>
+              <a:t>3/20/2026</a:t>
             </a:fld>
             <a:endParaRPr lang="en-US"/>
           </a:p>
@@ -3125,7 +3120,7 @@
 </file>
 
 <file path=ppt/slides/slide1.xml><?xml version="1.0" encoding="utf-8"?>
-<p:sld xmlns:a="http://schemas.openxmlformats.org/drawingml/2006/main" xmlns:p="http://schemas.openxmlformats.org/presentationml/2006/main" xmlns:r="http://schemas.openxmlformats.org/officeDocument/2006/relationships">
+<p:sld xmlns:a="http://schemas.openxmlformats.org/drawingml/2006/main" xmlns:r="http://schemas.openxmlformats.org/officeDocument/2006/relationships" xmlns:p="http://schemas.openxmlformats.org/presentationml/2006/main">
   <p:cSld>
     <p:spTree>
       <p:nvGrpSpPr>
@@ -3133,7 +3128,14 @@
         <p:cNvGrpSpPr/>
         <p:nvPr/>
       </p:nvGrpSpPr>
-      <p:grpSpPr/>
+      <p:grpSpPr>
+        <a:xfrm>
+          <a:off x="0" y="0"/>
+          <a:ext cx="0" cy="0"/>
+          <a:chOff x="0" y="0"/>
+          <a:chExt cx="0" cy="0"/>
+        </a:xfrm>
+      </p:grpSpPr>
       <p:sp>
         <p:nvSpPr>
           <p:cNvPr id="2" name="Rectangle 1"/>
@@ -3174,6 +3176,7 @@
           <a:lstStyle/>
           <a:p>
             <a:pPr algn="ctr"/>
+            <a:endParaRPr/>
           </a:p>
         </p:txBody>
       </p:sp>
@@ -3217,6 +3220,7 @@
           <a:lstStyle/>
           <a:p>
             <a:pPr algn="ctr"/>
+            <a:endParaRPr/>
           </a:p>
         </p:txBody>
       </p:sp>
@@ -3334,7 +3338,7 @@
 </file>
 
 <file path=ppt/slides/slide10.xml><?xml version="1.0" encoding="utf-8"?>
-<p:sld xmlns:a="http://schemas.openxmlformats.org/drawingml/2006/main" xmlns:p="http://schemas.openxmlformats.org/presentationml/2006/main" xmlns:r="http://schemas.openxmlformats.org/officeDocument/2006/relationships">
+<p:sld xmlns:a="http://schemas.openxmlformats.org/drawingml/2006/main" xmlns:r="http://schemas.openxmlformats.org/officeDocument/2006/relationships" xmlns:p="http://schemas.openxmlformats.org/presentationml/2006/main">
   <p:cSld>
     <p:spTree>
       <p:nvGrpSpPr>
@@ -3342,7 +3346,14 @@
         <p:cNvGrpSpPr/>
         <p:nvPr/>
       </p:nvGrpSpPr>
-      <p:grpSpPr/>
+      <p:grpSpPr>
+        <a:xfrm>
+          <a:off x="0" y="0"/>
+          <a:ext cx="0" cy="0"/>
+          <a:chOff x="0" y="0"/>
+          <a:chExt cx="0" cy="0"/>
+        </a:xfrm>
+      </p:grpSpPr>
       <p:sp>
         <p:nvSpPr>
           <p:cNvPr id="2" name="Rectangle 1"/>
@@ -3383,6 +3394,7 @@
           <a:lstStyle/>
           <a:p>
             <a:pPr algn="ctr"/>
+            <a:endParaRPr/>
           </a:p>
         </p:txBody>
       </p:sp>
@@ -3426,6 +3438,7 @@
           <a:lstStyle/>
           <a:p>
             <a:pPr algn="ctr"/>
+            <a:endParaRPr/>
           </a:p>
         </p:txBody>
       </p:sp>
@@ -3483,8 +3496,20 @@
                 <a:tableStyleId>{5C22544A-7EE6-4342-B048-85BDC9FD1C3A}</a:tableStyleId>
               </a:tblPr>
               <a:tblGrid>
-                <a:gridCol w="4023360"/>
-                <a:gridCol w="4023360"/>
+                <a:gridCol w="4023360">
+                  <a:extLst>
+                    <a:ext uri="{9D8B030D-6E8A-4147-A177-3AD203B41FA5}">
+                      <a16:colId xmlns:a16="http://schemas.microsoft.com/office/drawing/2014/main" val="20000"/>
+                    </a:ext>
+                  </a:extLst>
+                </a:gridCol>
+                <a:gridCol w="4023360">
+                  <a:extLst>
+                    <a:ext uri="{9D8B030D-6E8A-4147-A177-3AD203B41FA5}">
+                      <a16:colId xmlns:a16="http://schemas.microsoft.com/office/drawing/2014/main" val="20001"/>
+                    </a:ext>
+                  </a:extLst>
+                </a:gridCol>
               </a:tblGrid>
               <a:tr h="792480">
                 <a:tc>
@@ -3533,6 +3558,11 @@
                     </a:solidFill>
                   </a:tcPr>
                 </a:tc>
+                <a:extLst>
+                  <a:ext uri="{0D108BD9-81ED-4DB2-BD59-A6C34878D82A}">
+                    <a16:rowId xmlns:a16="http://schemas.microsoft.com/office/drawing/2014/main" val="10000"/>
+                  </a:ext>
+                </a:extLst>
               </a:tr>
               <a:tr h="792480">
                 <a:tc>
@@ -3581,6 +3611,11 @@
                     </a:solidFill>
                   </a:tcPr>
                 </a:tc>
+                <a:extLst>
+                  <a:ext uri="{0D108BD9-81ED-4DB2-BD59-A6C34878D82A}">
+                    <a16:rowId xmlns:a16="http://schemas.microsoft.com/office/drawing/2014/main" val="10001"/>
+                  </a:ext>
+                </a:extLst>
               </a:tr>
               <a:tr h="792480">
                 <a:tc>
@@ -3629,6 +3664,11 @@
                     </a:solidFill>
                   </a:tcPr>
                 </a:tc>
+                <a:extLst>
+                  <a:ext uri="{0D108BD9-81ED-4DB2-BD59-A6C34878D82A}">
+                    <a16:rowId xmlns:a16="http://schemas.microsoft.com/office/drawing/2014/main" val="10002"/>
+                  </a:ext>
+                </a:extLst>
               </a:tr>
               <a:tr h="792480">
                 <a:tc>
@@ -3677,6 +3717,11 @@
                     </a:solidFill>
                   </a:tcPr>
                 </a:tc>
+                <a:extLst>
+                  <a:ext uri="{0D108BD9-81ED-4DB2-BD59-A6C34878D82A}">
+                    <a16:rowId xmlns:a16="http://schemas.microsoft.com/office/drawing/2014/main" val="10003"/>
+                  </a:ext>
+                </a:extLst>
               </a:tr>
               <a:tr h="792480">
                 <a:tc>
@@ -3725,6 +3770,11 @@
                     </a:solidFill>
                   </a:tcPr>
                 </a:tc>
+                <a:extLst>
+                  <a:ext uri="{0D108BD9-81ED-4DB2-BD59-A6C34878D82A}">
+                    <a16:rowId xmlns:a16="http://schemas.microsoft.com/office/drawing/2014/main" val="10004"/>
+                  </a:ext>
+                </a:extLst>
               </a:tr>
               <a:tr h="792480">
                 <a:tc>
@@ -3773,6 +3823,11 @@
                     </a:solidFill>
                   </a:tcPr>
                 </a:tc>
+                <a:extLst>
+                  <a:ext uri="{0D108BD9-81ED-4DB2-BD59-A6C34878D82A}">
+                    <a16:rowId xmlns:a16="http://schemas.microsoft.com/office/drawing/2014/main" val="10005"/>
+                  </a:ext>
+                </a:extLst>
               </a:tr>
             </a:tbl>
           </a:graphicData>
@@ -3822,7 +3877,7 @@
 </file>
 
 <file path=ppt/slides/slide11.xml><?xml version="1.0" encoding="utf-8"?>
-<p:sld xmlns:a="http://schemas.openxmlformats.org/drawingml/2006/main" xmlns:p="http://schemas.openxmlformats.org/presentationml/2006/main" xmlns:r="http://schemas.openxmlformats.org/officeDocument/2006/relationships">
+<p:sld xmlns:a="http://schemas.openxmlformats.org/drawingml/2006/main" xmlns:r="http://schemas.openxmlformats.org/officeDocument/2006/relationships" xmlns:p="http://schemas.openxmlformats.org/presentationml/2006/main">
   <p:cSld>
     <p:spTree>
       <p:nvGrpSpPr>
@@ -3830,7 +3885,14 @@
         <p:cNvGrpSpPr/>
         <p:nvPr/>
       </p:nvGrpSpPr>
-      <p:grpSpPr/>
+      <p:grpSpPr>
+        <a:xfrm>
+          <a:off x="0" y="0"/>
+          <a:ext cx="0" cy="0"/>
+          <a:chOff x="0" y="0"/>
+          <a:chExt cx="0" cy="0"/>
+        </a:xfrm>
+      </p:grpSpPr>
       <p:sp>
         <p:nvSpPr>
           <p:cNvPr id="2" name="Rectangle 1"/>
@@ -3871,6 +3933,7 @@
           <a:lstStyle/>
           <a:p>
             <a:pPr algn="ctr"/>
+            <a:endParaRPr/>
           </a:p>
         </p:txBody>
       </p:sp>
@@ -3914,6 +3977,7 @@
           <a:lstStyle/>
           <a:p>
             <a:pPr algn="ctr"/>
+            <a:endParaRPr/>
           </a:p>
         </p:txBody>
       </p:sp>
@@ -4114,7 +4178,7 @@
 </file>
 
 <file path=ppt/slides/slide12.xml><?xml version="1.0" encoding="utf-8"?>
-<p:sld xmlns:a="http://schemas.openxmlformats.org/drawingml/2006/main" xmlns:p="http://schemas.openxmlformats.org/presentationml/2006/main" xmlns:r="http://schemas.openxmlformats.org/officeDocument/2006/relationships">
+<p:sld xmlns:a="http://schemas.openxmlformats.org/drawingml/2006/main" xmlns:r="http://schemas.openxmlformats.org/officeDocument/2006/relationships" xmlns:p="http://schemas.openxmlformats.org/presentationml/2006/main">
   <p:cSld>
     <p:spTree>
       <p:nvGrpSpPr>
@@ -4122,7 +4186,14 @@
         <p:cNvGrpSpPr/>
         <p:nvPr/>
       </p:nvGrpSpPr>
-      <p:grpSpPr/>
+      <p:grpSpPr>
+        <a:xfrm>
+          <a:off x="0" y="0"/>
+          <a:ext cx="0" cy="0"/>
+          <a:chOff x="0" y="0"/>
+          <a:chExt cx="0" cy="0"/>
+        </a:xfrm>
+      </p:grpSpPr>
       <p:sp>
         <p:nvSpPr>
           <p:cNvPr id="2" name="Rectangle 1"/>
@@ -4163,6 +4234,7 @@
           <a:lstStyle/>
           <a:p>
             <a:pPr algn="ctr"/>
+            <a:endParaRPr/>
           </a:p>
         </p:txBody>
       </p:sp>
@@ -4206,6 +4278,7 @@
           <a:lstStyle/>
           <a:p>
             <a:pPr algn="ctr"/>
+            <a:endParaRPr/>
           </a:p>
         </p:txBody>
       </p:sp>
@@ -4387,7 +4460,7 @@
 </file>
 
 <file path=ppt/slides/slide13.xml><?xml version="1.0" encoding="utf-8"?>
-<p:sld xmlns:a="http://schemas.openxmlformats.org/drawingml/2006/main" xmlns:p="http://schemas.openxmlformats.org/presentationml/2006/main" xmlns:r="http://schemas.openxmlformats.org/officeDocument/2006/relationships">
+<p:sld xmlns:a="http://schemas.openxmlformats.org/drawingml/2006/main" xmlns:r="http://schemas.openxmlformats.org/officeDocument/2006/relationships" xmlns:p="http://schemas.openxmlformats.org/presentationml/2006/main">
   <p:cSld>
     <p:spTree>
       <p:nvGrpSpPr>
@@ -4395,7 +4468,14 @@
         <p:cNvGrpSpPr/>
         <p:nvPr/>
       </p:nvGrpSpPr>
-      <p:grpSpPr/>
+      <p:grpSpPr>
+        <a:xfrm>
+          <a:off x="0" y="0"/>
+          <a:ext cx="0" cy="0"/>
+          <a:chOff x="0" y="0"/>
+          <a:chExt cx="0" cy="0"/>
+        </a:xfrm>
+      </p:grpSpPr>
       <p:sp>
         <p:nvSpPr>
           <p:cNvPr id="2" name="Rectangle 1"/>
@@ -4436,6 +4516,7 @@
           <a:lstStyle/>
           <a:p>
             <a:pPr algn="ctr"/>
+            <a:endParaRPr/>
           </a:p>
         </p:txBody>
       </p:sp>
@@ -4479,6 +4560,7 @@
           <a:lstStyle/>
           <a:p>
             <a:pPr algn="ctr"/>
+            <a:endParaRPr/>
           </a:p>
         </p:txBody>
       </p:sp>
@@ -4526,7 +4608,7 @@
 </file>
 
 <file path=ppt/slides/slide14.xml><?xml version="1.0" encoding="utf-8"?>
-<p:sld xmlns:a="http://schemas.openxmlformats.org/drawingml/2006/main" xmlns:p="http://schemas.openxmlformats.org/presentationml/2006/main" xmlns:r="http://schemas.openxmlformats.org/officeDocument/2006/relationships">
+<p:sld xmlns:a="http://schemas.openxmlformats.org/drawingml/2006/main" xmlns:r="http://schemas.openxmlformats.org/officeDocument/2006/relationships" xmlns:p="http://schemas.openxmlformats.org/presentationml/2006/main">
   <p:cSld>
     <p:spTree>
       <p:nvGrpSpPr>
@@ -4534,7 +4616,14 @@
         <p:cNvGrpSpPr/>
         <p:nvPr/>
       </p:nvGrpSpPr>
-      <p:grpSpPr/>
+      <p:grpSpPr>
+        <a:xfrm>
+          <a:off x="0" y="0"/>
+          <a:ext cx="0" cy="0"/>
+          <a:chOff x="0" y="0"/>
+          <a:chExt cx="0" cy="0"/>
+        </a:xfrm>
+      </p:grpSpPr>
       <p:sp>
         <p:nvSpPr>
           <p:cNvPr id="2" name="Rectangle 1"/>
@@ -4575,6 +4664,7 @@
           <a:lstStyle/>
           <a:p>
             <a:pPr algn="ctr"/>
+            <a:endParaRPr/>
           </a:p>
         </p:txBody>
       </p:sp>
@@ -4618,6 +4708,7 @@
           <a:lstStyle/>
           <a:p>
             <a:pPr algn="ctr"/>
+            <a:endParaRPr/>
           </a:p>
         </p:txBody>
       </p:sp>
@@ -4818,7 +4909,7 @@
 </file>
 
 <file path=ppt/slides/slide15.xml><?xml version="1.0" encoding="utf-8"?>
-<p:sld xmlns:a="http://schemas.openxmlformats.org/drawingml/2006/main" xmlns:p="http://schemas.openxmlformats.org/presentationml/2006/main" xmlns:r="http://schemas.openxmlformats.org/officeDocument/2006/relationships">
+<p:sld xmlns:a="http://schemas.openxmlformats.org/drawingml/2006/main" xmlns:r="http://schemas.openxmlformats.org/officeDocument/2006/relationships" xmlns:p="http://schemas.openxmlformats.org/presentationml/2006/main">
   <p:cSld>
     <p:spTree>
       <p:nvGrpSpPr>
@@ -4826,7 +4917,14 @@
         <p:cNvGrpSpPr/>
         <p:nvPr/>
       </p:nvGrpSpPr>
-      <p:grpSpPr/>
+      <p:grpSpPr>
+        <a:xfrm>
+          <a:off x="0" y="0"/>
+          <a:ext cx="0" cy="0"/>
+          <a:chOff x="0" y="0"/>
+          <a:chExt cx="0" cy="0"/>
+        </a:xfrm>
+      </p:grpSpPr>
       <p:sp>
         <p:nvSpPr>
           <p:cNvPr id="2" name="Rectangle 1"/>
@@ -4867,6 +4965,7 @@
           <a:lstStyle/>
           <a:p>
             <a:pPr algn="ctr"/>
+            <a:endParaRPr/>
           </a:p>
         </p:txBody>
       </p:sp>
@@ -4910,6 +5009,7 @@
           <a:lstStyle/>
           <a:p>
             <a:pPr algn="ctr"/>
+            <a:endParaRPr/>
           </a:p>
         </p:txBody>
       </p:sp>
@@ -5110,7 +5210,7 @@
 </file>
 
 <file path=ppt/slides/slide16.xml><?xml version="1.0" encoding="utf-8"?>
-<p:sld xmlns:a="http://schemas.openxmlformats.org/drawingml/2006/main" xmlns:p="http://schemas.openxmlformats.org/presentationml/2006/main" xmlns:r="http://schemas.openxmlformats.org/officeDocument/2006/relationships">
+<p:sld xmlns:a="http://schemas.openxmlformats.org/drawingml/2006/main" xmlns:r="http://schemas.openxmlformats.org/officeDocument/2006/relationships" xmlns:p="http://schemas.openxmlformats.org/presentationml/2006/main">
   <p:cSld>
     <p:spTree>
       <p:nvGrpSpPr>
@@ -5118,7 +5218,14 @@
         <p:cNvGrpSpPr/>
         <p:nvPr/>
       </p:nvGrpSpPr>
-      <p:grpSpPr/>
+      <p:grpSpPr>
+        <a:xfrm>
+          <a:off x="0" y="0"/>
+          <a:ext cx="0" cy="0"/>
+          <a:chOff x="0" y="0"/>
+          <a:chExt cx="0" cy="0"/>
+        </a:xfrm>
+      </p:grpSpPr>
       <p:sp>
         <p:nvSpPr>
           <p:cNvPr id="2" name="Rectangle 1"/>
@@ -5159,6 +5266,7 @@
           <a:lstStyle/>
           <a:p>
             <a:pPr algn="ctr"/>
+            <a:endParaRPr/>
           </a:p>
         </p:txBody>
       </p:sp>
@@ -5202,6 +5310,7 @@
           <a:lstStyle/>
           <a:p>
             <a:pPr algn="ctr"/>
+            <a:endParaRPr/>
           </a:p>
         </p:txBody>
       </p:sp>
@@ -5259,9 +5368,27 @@
                 <a:tableStyleId>{5C22544A-7EE6-4342-B048-85BDC9FD1C3A}</a:tableStyleId>
               </a:tblPr>
               <a:tblGrid>
-                <a:gridCol w="2682240"/>
-                <a:gridCol w="2682240"/>
-                <a:gridCol w="2682240"/>
+                <a:gridCol w="2682240">
+                  <a:extLst>
+                    <a:ext uri="{9D8B030D-6E8A-4147-A177-3AD203B41FA5}">
+                      <a16:colId xmlns:a16="http://schemas.microsoft.com/office/drawing/2014/main" val="20000"/>
+                    </a:ext>
+                  </a:extLst>
+                </a:gridCol>
+                <a:gridCol w="2682240">
+                  <a:extLst>
+                    <a:ext uri="{9D8B030D-6E8A-4147-A177-3AD203B41FA5}">
+                      <a16:colId xmlns:a16="http://schemas.microsoft.com/office/drawing/2014/main" val="20001"/>
+                    </a:ext>
+                  </a:extLst>
+                </a:gridCol>
+                <a:gridCol w="2682240">
+                  <a:extLst>
+                    <a:ext uri="{9D8B030D-6E8A-4147-A177-3AD203B41FA5}">
+                      <a16:colId xmlns:a16="http://schemas.microsoft.com/office/drawing/2014/main" val="20002"/>
+                    </a:ext>
+                  </a:extLst>
+                </a:gridCol>
               </a:tblGrid>
               <a:tr h="950976">
                 <a:tc>
@@ -5333,6 +5460,11 @@
                     </a:solidFill>
                   </a:tcPr>
                 </a:tc>
+                <a:extLst>
+                  <a:ext uri="{0D108BD9-81ED-4DB2-BD59-A6C34878D82A}">
+                    <a16:rowId xmlns:a16="http://schemas.microsoft.com/office/drawing/2014/main" val="10000"/>
+                  </a:ext>
+                </a:extLst>
               </a:tr>
               <a:tr h="950976">
                 <a:tc>
@@ -5404,6 +5536,11 @@
                     </a:solidFill>
                   </a:tcPr>
                 </a:tc>
+                <a:extLst>
+                  <a:ext uri="{0D108BD9-81ED-4DB2-BD59-A6C34878D82A}">
+                    <a16:rowId xmlns:a16="http://schemas.microsoft.com/office/drawing/2014/main" val="10001"/>
+                  </a:ext>
+                </a:extLst>
               </a:tr>
               <a:tr h="950976">
                 <a:tc>
@@ -5475,6 +5612,11 @@
                     </a:solidFill>
                   </a:tcPr>
                 </a:tc>
+                <a:extLst>
+                  <a:ext uri="{0D108BD9-81ED-4DB2-BD59-A6C34878D82A}">
+                    <a16:rowId xmlns:a16="http://schemas.microsoft.com/office/drawing/2014/main" val="10002"/>
+                  </a:ext>
+                </a:extLst>
               </a:tr>
               <a:tr h="950976">
                 <a:tc>
@@ -5546,6 +5688,11 @@
                     </a:solidFill>
                   </a:tcPr>
                 </a:tc>
+                <a:extLst>
+                  <a:ext uri="{0D108BD9-81ED-4DB2-BD59-A6C34878D82A}">
+                    <a16:rowId xmlns:a16="http://schemas.microsoft.com/office/drawing/2014/main" val="10003"/>
+                  </a:ext>
+                </a:extLst>
               </a:tr>
               <a:tr h="950976">
                 <a:tc>
@@ -5617,6 +5764,11 @@
                     </a:solidFill>
                   </a:tcPr>
                 </a:tc>
+                <a:extLst>
+                  <a:ext uri="{0D108BD9-81ED-4DB2-BD59-A6C34878D82A}">
+                    <a16:rowId xmlns:a16="http://schemas.microsoft.com/office/drawing/2014/main" val="10004"/>
+                  </a:ext>
+                </a:extLst>
               </a:tr>
             </a:tbl>
           </a:graphicData>
@@ -5666,7 +5818,7 @@
 </file>
 
 <file path=ppt/slides/slide17.xml><?xml version="1.0" encoding="utf-8"?>
-<p:sld xmlns:a="http://schemas.openxmlformats.org/drawingml/2006/main" xmlns:p="http://schemas.openxmlformats.org/presentationml/2006/main" xmlns:r="http://schemas.openxmlformats.org/officeDocument/2006/relationships">
+<p:sld xmlns:a="http://schemas.openxmlformats.org/drawingml/2006/main" xmlns:r="http://schemas.openxmlformats.org/officeDocument/2006/relationships" xmlns:p="http://schemas.openxmlformats.org/presentationml/2006/main">
   <p:cSld>
     <p:spTree>
       <p:nvGrpSpPr>
@@ -5674,7 +5826,14 @@
         <p:cNvGrpSpPr/>
         <p:nvPr/>
       </p:nvGrpSpPr>
-      <p:grpSpPr/>
+      <p:grpSpPr>
+        <a:xfrm>
+          <a:off x="0" y="0"/>
+          <a:ext cx="0" cy="0"/>
+          <a:chOff x="0" y="0"/>
+          <a:chExt cx="0" cy="0"/>
+        </a:xfrm>
+      </p:grpSpPr>
       <p:sp>
         <p:nvSpPr>
           <p:cNvPr id="2" name="Rectangle 1"/>
@@ -5715,6 +5874,7 @@
           <a:lstStyle/>
           <a:p>
             <a:pPr algn="ctr"/>
+            <a:endParaRPr/>
           </a:p>
         </p:txBody>
       </p:sp>
@@ -5758,6 +5918,7 @@
           <a:lstStyle/>
           <a:p>
             <a:pPr algn="ctr"/>
+            <a:endParaRPr/>
           </a:p>
         </p:txBody>
       </p:sp>
@@ -5939,7 +6100,7 @@
 </file>
 
 <file path=ppt/slides/slide18.xml><?xml version="1.0" encoding="utf-8"?>
-<p:sld xmlns:a="http://schemas.openxmlformats.org/drawingml/2006/main" xmlns:p="http://schemas.openxmlformats.org/presentationml/2006/main" xmlns:r="http://schemas.openxmlformats.org/officeDocument/2006/relationships">
+<p:sld xmlns:a="http://schemas.openxmlformats.org/drawingml/2006/main" xmlns:r="http://schemas.openxmlformats.org/officeDocument/2006/relationships" xmlns:p="http://schemas.openxmlformats.org/presentationml/2006/main">
   <p:cSld>
     <p:spTree>
       <p:nvGrpSpPr>
@@ -5947,7 +6108,14 @@
         <p:cNvGrpSpPr/>
         <p:nvPr/>
       </p:nvGrpSpPr>
-      <p:grpSpPr/>
+      <p:grpSpPr>
+        <a:xfrm>
+          <a:off x="0" y="0"/>
+          <a:ext cx="0" cy="0"/>
+          <a:chOff x="0" y="0"/>
+          <a:chExt cx="0" cy="0"/>
+        </a:xfrm>
+      </p:grpSpPr>
       <p:sp>
         <p:nvSpPr>
           <p:cNvPr id="2" name="Rectangle 1"/>
@@ -5988,6 +6156,7 @@
           <a:lstStyle/>
           <a:p>
             <a:pPr algn="ctr"/>
+            <a:endParaRPr/>
           </a:p>
         </p:txBody>
       </p:sp>
@@ -6031,6 +6200,7 @@
           <a:lstStyle/>
           <a:p>
             <a:pPr algn="ctr"/>
+            <a:endParaRPr/>
           </a:p>
         </p:txBody>
       </p:sp>
@@ -6231,7 +6401,7 @@
 </file>
 
 <file path=ppt/slides/slide19.xml><?xml version="1.0" encoding="utf-8"?>
-<p:sld xmlns:a="http://schemas.openxmlformats.org/drawingml/2006/main" xmlns:p="http://schemas.openxmlformats.org/presentationml/2006/main" xmlns:r="http://schemas.openxmlformats.org/officeDocument/2006/relationships">
+<p:sld xmlns:a="http://schemas.openxmlformats.org/drawingml/2006/main" xmlns:r="http://schemas.openxmlformats.org/officeDocument/2006/relationships" xmlns:p="http://schemas.openxmlformats.org/presentationml/2006/main">
   <p:cSld>
     <p:spTree>
       <p:nvGrpSpPr>
@@ -6239,7 +6409,14 @@
         <p:cNvGrpSpPr/>
         <p:nvPr/>
       </p:nvGrpSpPr>
-      <p:grpSpPr/>
+      <p:grpSpPr>
+        <a:xfrm>
+          <a:off x="0" y="0"/>
+          <a:ext cx="0" cy="0"/>
+          <a:chOff x="0" y="0"/>
+          <a:chExt cx="0" cy="0"/>
+        </a:xfrm>
+      </p:grpSpPr>
       <p:sp>
         <p:nvSpPr>
           <p:cNvPr id="2" name="Rectangle 1"/>
@@ -6280,6 +6457,7 @@
           <a:lstStyle/>
           <a:p>
             <a:pPr algn="ctr"/>
+            <a:endParaRPr/>
           </a:p>
         </p:txBody>
       </p:sp>
@@ -6323,6 +6501,7 @@
           <a:lstStyle/>
           <a:p>
             <a:pPr algn="ctr"/>
+            <a:endParaRPr/>
           </a:p>
         </p:txBody>
       </p:sp>
@@ -6580,7 +6759,7 @@
 </file>
 
 <file path=ppt/slides/slide2.xml><?xml version="1.0" encoding="utf-8"?>
-<p:sld xmlns:a="http://schemas.openxmlformats.org/drawingml/2006/main" xmlns:p="http://schemas.openxmlformats.org/presentationml/2006/main" xmlns:r="http://schemas.openxmlformats.org/officeDocument/2006/relationships">
+<p:sld xmlns:a="http://schemas.openxmlformats.org/drawingml/2006/main" xmlns:r="http://schemas.openxmlformats.org/officeDocument/2006/relationships" xmlns:p="http://schemas.openxmlformats.org/presentationml/2006/main">
   <p:cSld>
     <p:spTree>
       <p:nvGrpSpPr>
@@ -6588,7 +6767,14 @@
         <p:cNvGrpSpPr/>
         <p:nvPr/>
       </p:nvGrpSpPr>
-      <p:grpSpPr/>
+      <p:grpSpPr>
+        <a:xfrm>
+          <a:off x="0" y="0"/>
+          <a:ext cx="0" cy="0"/>
+          <a:chOff x="0" y="0"/>
+          <a:chExt cx="0" cy="0"/>
+        </a:xfrm>
+      </p:grpSpPr>
       <p:sp>
         <p:nvSpPr>
           <p:cNvPr id="2" name="Rectangle 1"/>
@@ -6629,6 +6815,7 @@
           <a:lstStyle/>
           <a:p>
             <a:pPr algn="ctr"/>
+            <a:endParaRPr/>
           </a:p>
         </p:txBody>
       </p:sp>
@@ -6672,6 +6859,7 @@
           <a:lstStyle/>
           <a:p>
             <a:pPr algn="ctr"/>
+            <a:endParaRPr/>
           </a:p>
         </p:txBody>
       </p:sp>
@@ -6750,6 +6938,7 @@
           <a:lstStyle/>
           <a:p>
             <a:pPr algn="ctr"/>
+            <a:endParaRPr/>
           </a:p>
         </p:txBody>
       </p:sp>
@@ -6795,6 +6984,7 @@
           <a:lstStyle/>
           <a:p>
             <a:pPr algn="ctr"/>
+            <a:endParaRPr/>
           </a:p>
         </p:txBody>
       </p:sp>
@@ -6873,6 +7063,7 @@
           <a:lstStyle/>
           <a:p>
             <a:pPr algn="ctr"/>
+            <a:endParaRPr/>
           </a:p>
         </p:txBody>
       </p:sp>
@@ -6918,6 +7109,7 @@
           <a:lstStyle/>
           <a:p>
             <a:pPr algn="ctr"/>
+            <a:endParaRPr/>
           </a:p>
         </p:txBody>
       </p:sp>
@@ -6996,6 +7188,7 @@
           <a:lstStyle/>
           <a:p>
             <a:pPr algn="ctr"/>
+            <a:endParaRPr/>
           </a:p>
         </p:txBody>
       </p:sp>
@@ -7041,6 +7234,7 @@
           <a:lstStyle/>
           <a:p>
             <a:pPr algn="ctr"/>
+            <a:endParaRPr/>
           </a:p>
         </p:txBody>
       </p:sp>
@@ -7119,6 +7313,7 @@
           <a:lstStyle/>
           <a:p>
             <a:pPr algn="ctr"/>
+            <a:endParaRPr/>
           </a:p>
         </p:txBody>
       </p:sp>
@@ -7164,6 +7359,7 @@
           <a:lstStyle/>
           <a:p>
             <a:pPr algn="ctr"/>
+            <a:endParaRPr/>
           </a:p>
         </p:txBody>
       </p:sp>
@@ -7246,7 +7442,7 @@
 </file>
 
 <file path=ppt/slides/slide20.xml><?xml version="1.0" encoding="utf-8"?>
-<p:sld xmlns:a="http://schemas.openxmlformats.org/drawingml/2006/main" xmlns:p="http://schemas.openxmlformats.org/presentationml/2006/main" xmlns:r="http://schemas.openxmlformats.org/officeDocument/2006/relationships">
+<p:sld xmlns:a="http://schemas.openxmlformats.org/drawingml/2006/main" xmlns:r="http://schemas.openxmlformats.org/officeDocument/2006/relationships" xmlns:p="http://schemas.openxmlformats.org/presentationml/2006/main">
   <p:cSld>
     <p:spTree>
       <p:nvGrpSpPr>
@@ -7254,7 +7450,14 @@
         <p:cNvGrpSpPr/>
         <p:nvPr/>
       </p:nvGrpSpPr>
-      <p:grpSpPr/>
+      <p:grpSpPr>
+        <a:xfrm>
+          <a:off x="0" y="0"/>
+          <a:ext cx="0" cy="0"/>
+          <a:chOff x="0" y="0"/>
+          <a:chExt cx="0" cy="0"/>
+        </a:xfrm>
+      </p:grpSpPr>
       <p:sp>
         <p:nvSpPr>
           <p:cNvPr id="2" name="Rectangle 1"/>
@@ -7295,6 +7498,7 @@
           <a:lstStyle/>
           <a:p>
             <a:pPr algn="ctr"/>
+            <a:endParaRPr/>
           </a:p>
         </p:txBody>
       </p:sp>
@@ -7338,6 +7542,7 @@
           <a:lstStyle/>
           <a:p>
             <a:pPr algn="ctr"/>
+            <a:endParaRPr/>
           </a:p>
         </p:txBody>
       </p:sp>
@@ -7395,11 +7600,41 @@
                 <a:tableStyleId>{5C22544A-7EE6-4342-B048-85BDC9FD1C3A}</a:tableStyleId>
               </a:tblPr>
               <a:tblGrid>
-                <a:gridCol w="1609344"/>
-                <a:gridCol w="1609344"/>
-                <a:gridCol w="1609344"/>
-                <a:gridCol w="1609344"/>
-                <a:gridCol w="1609344"/>
+                <a:gridCol w="1609344">
+                  <a:extLst>
+                    <a:ext uri="{9D8B030D-6E8A-4147-A177-3AD203B41FA5}">
+                      <a16:colId xmlns:a16="http://schemas.microsoft.com/office/drawing/2014/main" val="20000"/>
+                    </a:ext>
+                  </a:extLst>
+                </a:gridCol>
+                <a:gridCol w="1609344">
+                  <a:extLst>
+                    <a:ext uri="{9D8B030D-6E8A-4147-A177-3AD203B41FA5}">
+                      <a16:colId xmlns:a16="http://schemas.microsoft.com/office/drawing/2014/main" val="20001"/>
+                    </a:ext>
+                  </a:extLst>
+                </a:gridCol>
+                <a:gridCol w="1609344">
+                  <a:extLst>
+                    <a:ext uri="{9D8B030D-6E8A-4147-A177-3AD203B41FA5}">
+                      <a16:colId xmlns:a16="http://schemas.microsoft.com/office/drawing/2014/main" val="20002"/>
+                    </a:ext>
+                  </a:extLst>
+                </a:gridCol>
+                <a:gridCol w="1609344">
+                  <a:extLst>
+                    <a:ext uri="{9D8B030D-6E8A-4147-A177-3AD203B41FA5}">
+                      <a16:colId xmlns:a16="http://schemas.microsoft.com/office/drawing/2014/main" val="20003"/>
+                    </a:ext>
+                  </a:extLst>
+                </a:gridCol>
+                <a:gridCol w="1609344">
+                  <a:extLst>
+                    <a:ext uri="{9D8B030D-6E8A-4147-A177-3AD203B41FA5}">
+                      <a16:colId xmlns:a16="http://schemas.microsoft.com/office/drawing/2014/main" val="20004"/>
+                    </a:ext>
+                  </a:extLst>
+                </a:gridCol>
               </a:tblGrid>
               <a:tr h="1188720">
                 <a:tc>
@@ -7517,6 +7752,11 @@
                     </a:solidFill>
                   </a:tcPr>
                 </a:tc>
+                <a:extLst>
+                  <a:ext uri="{0D108BD9-81ED-4DB2-BD59-A6C34878D82A}">
+                    <a16:rowId xmlns:a16="http://schemas.microsoft.com/office/drawing/2014/main" val="10000"/>
+                  </a:ext>
+                </a:extLst>
               </a:tr>
               <a:tr h="1188720">
                 <a:tc>
@@ -7634,6 +7874,11 @@
                     </a:solidFill>
                   </a:tcPr>
                 </a:tc>
+                <a:extLst>
+                  <a:ext uri="{0D108BD9-81ED-4DB2-BD59-A6C34878D82A}">
+                    <a16:rowId xmlns:a16="http://schemas.microsoft.com/office/drawing/2014/main" val="10001"/>
+                  </a:ext>
+                </a:extLst>
               </a:tr>
               <a:tr h="1188720">
                 <a:tc>
@@ -7751,6 +7996,11 @@
                     </a:solidFill>
                   </a:tcPr>
                 </a:tc>
+                <a:extLst>
+                  <a:ext uri="{0D108BD9-81ED-4DB2-BD59-A6C34878D82A}">
+                    <a16:rowId xmlns:a16="http://schemas.microsoft.com/office/drawing/2014/main" val="10002"/>
+                  </a:ext>
+                </a:extLst>
               </a:tr>
               <a:tr h="1188720">
                 <a:tc>
@@ -7868,6 +8118,11 @@
                     </a:solidFill>
                   </a:tcPr>
                 </a:tc>
+                <a:extLst>
+                  <a:ext uri="{0D108BD9-81ED-4DB2-BD59-A6C34878D82A}">
+                    <a16:rowId xmlns:a16="http://schemas.microsoft.com/office/drawing/2014/main" val="10003"/>
+                  </a:ext>
+                </a:extLst>
               </a:tr>
             </a:tbl>
           </a:graphicData>
@@ -7917,7 +8172,7 @@
 </file>
 
 <file path=ppt/slides/slide21.xml><?xml version="1.0" encoding="utf-8"?>
-<p:sld xmlns:a="http://schemas.openxmlformats.org/drawingml/2006/main" xmlns:p="http://schemas.openxmlformats.org/presentationml/2006/main" xmlns:r="http://schemas.openxmlformats.org/officeDocument/2006/relationships">
+<p:sld xmlns:a="http://schemas.openxmlformats.org/drawingml/2006/main" xmlns:r="http://schemas.openxmlformats.org/officeDocument/2006/relationships" xmlns:p="http://schemas.openxmlformats.org/presentationml/2006/main">
   <p:cSld>
     <p:spTree>
       <p:nvGrpSpPr>
@@ -7925,7 +8180,14 @@
         <p:cNvGrpSpPr/>
         <p:nvPr/>
       </p:nvGrpSpPr>
-      <p:grpSpPr/>
+      <p:grpSpPr>
+        <a:xfrm>
+          <a:off x="0" y="0"/>
+          <a:ext cx="0" cy="0"/>
+          <a:chOff x="0" y="0"/>
+          <a:chExt cx="0" cy="0"/>
+        </a:xfrm>
+      </p:grpSpPr>
       <p:sp>
         <p:nvSpPr>
           <p:cNvPr id="2" name="Rectangle 1"/>
@@ -7966,6 +8228,7 @@
           <a:lstStyle/>
           <a:p>
             <a:pPr algn="ctr"/>
+            <a:endParaRPr/>
           </a:p>
         </p:txBody>
       </p:sp>
@@ -8009,6 +8272,7 @@
           <a:lstStyle/>
           <a:p>
             <a:pPr algn="ctr"/>
+            <a:endParaRPr/>
           </a:p>
         </p:txBody>
       </p:sp>
@@ -8247,7 +8511,7 @@
 </file>
 
 <file path=ppt/slides/slide22.xml><?xml version="1.0" encoding="utf-8"?>
-<p:sld xmlns:a="http://schemas.openxmlformats.org/drawingml/2006/main" xmlns:p="http://schemas.openxmlformats.org/presentationml/2006/main" xmlns:r="http://schemas.openxmlformats.org/officeDocument/2006/relationships">
+<p:sld xmlns:a="http://schemas.openxmlformats.org/drawingml/2006/main" xmlns:r="http://schemas.openxmlformats.org/officeDocument/2006/relationships" xmlns:p="http://schemas.openxmlformats.org/presentationml/2006/main">
   <p:cSld>
     <p:spTree>
       <p:nvGrpSpPr>
@@ -8255,7 +8519,14 @@
         <p:cNvGrpSpPr/>
         <p:nvPr/>
       </p:nvGrpSpPr>
-      <p:grpSpPr/>
+      <p:grpSpPr>
+        <a:xfrm>
+          <a:off x="0" y="0"/>
+          <a:ext cx="0" cy="0"/>
+          <a:chOff x="0" y="0"/>
+          <a:chExt cx="0" cy="0"/>
+        </a:xfrm>
+      </p:grpSpPr>
       <p:sp>
         <p:nvSpPr>
           <p:cNvPr id="2" name="Rectangle 1"/>
@@ -8296,6 +8567,7 @@
           <a:lstStyle/>
           <a:p>
             <a:pPr algn="ctr"/>
+            <a:endParaRPr/>
           </a:p>
         </p:txBody>
       </p:sp>
@@ -8339,6 +8611,7 @@
           <a:lstStyle/>
           <a:p>
             <a:pPr algn="ctr"/>
+            <a:endParaRPr/>
           </a:p>
         </p:txBody>
       </p:sp>
@@ -8577,7 +8850,7 @@
 </file>
 
 <file path=ppt/slides/slide23.xml><?xml version="1.0" encoding="utf-8"?>
-<p:sld xmlns:a="http://schemas.openxmlformats.org/drawingml/2006/main" xmlns:p="http://schemas.openxmlformats.org/presentationml/2006/main" xmlns:r="http://schemas.openxmlformats.org/officeDocument/2006/relationships">
+<p:sld xmlns:a="http://schemas.openxmlformats.org/drawingml/2006/main" xmlns:r="http://schemas.openxmlformats.org/officeDocument/2006/relationships" xmlns:p="http://schemas.openxmlformats.org/presentationml/2006/main">
   <p:cSld>
     <p:spTree>
       <p:nvGrpSpPr>
@@ -8585,7 +8858,14 @@
         <p:cNvGrpSpPr/>
         <p:nvPr/>
       </p:nvGrpSpPr>
-      <p:grpSpPr/>
+      <p:grpSpPr>
+        <a:xfrm>
+          <a:off x="0" y="0"/>
+          <a:ext cx="0" cy="0"/>
+          <a:chOff x="0" y="0"/>
+          <a:chExt cx="0" cy="0"/>
+        </a:xfrm>
+      </p:grpSpPr>
       <p:sp>
         <p:nvSpPr>
           <p:cNvPr id="2" name="Rectangle 1"/>
@@ -8626,6 +8906,7 @@
           <a:lstStyle/>
           <a:p>
             <a:pPr algn="ctr"/>
+            <a:endParaRPr/>
           </a:p>
         </p:txBody>
       </p:sp>
@@ -8669,6 +8950,7 @@
           <a:lstStyle/>
           <a:p>
             <a:pPr algn="ctr"/>
+            <a:endParaRPr/>
           </a:p>
         </p:txBody>
       </p:sp>
@@ -8869,7 +9151,7 @@
 </file>
 
 <file path=ppt/slides/slide24.xml><?xml version="1.0" encoding="utf-8"?>
-<p:sld xmlns:a="http://schemas.openxmlformats.org/drawingml/2006/main" xmlns:p="http://schemas.openxmlformats.org/presentationml/2006/main" xmlns:r="http://schemas.openxmlformats.org/officeDocument/2006/relationships">
+<p:sld xmlns:a="http://schemas.openxmlformats.org/drawingml/2006/main" xmlns:r="http://schemas.openxmlformats.org/officeDocument/2006/relationships" xmlns:p="http://schemas.openxmlformats.org/presentationml/2006/main">
   <p:cSld>
     <p:spTree>
       <p:nvGrpSpPr>
@@ -8877,7 +9159,14 @@
         <p:cNvGrpSpPr/>
         <p:nvPr/>
       </p:nvGrpSpPr>
-      <p:grpSpPr/>
+      <p:grpSpPr>
+        <a:xfrm>
+          <a:off x="0" y="0"/>
+          <a:ext cx="0" cy="0"/>
+          <a:chOff x="0" y="0"/>
+          <a:chExt cx="0" cy="0"/>
+        </a:xfrm>
+      </p:grpSpPr>
       <p:sp>
         <p:nvSpPr>
           <p:cNvPr id="2" name="Rectangle 1"/>
@@ -8918,6 +9207,7 @@
           <a:lstStyle/>
           <a:p>
             <a:pPr algn="ctr"/>
+            <a:endParaRPr/>
           </a:p>
         </p:txBody>
       </p:sp>
@@ -8961,6 +9251,7 @@
           <a:lstStyle/>
           <a:p>
             <a:pPr algn="ctr"/>
+            <a:endParaRPr/>
           </a:p>
         </p:txBody>
       </p:sp>
@@ -9180,7 +9471,7 @@
 </file>
 
 <file path=ppt/slides/slide25.xml><?xml version="1.0" encoding="utf-8"?>
-<p:sld xmlns:a="http://schemas.openxmlformats.org/drawingml/2006/main" xmlns:p="http://schemas.openxmlformats.org/presentationml/2006/main" xmlns:r="http://schemas.openxmlformats.org/officeDocument/2006/relationships">
+<p:sld xmlns:a="http://schemas.openxmlformats.org/drawingml/2006/main" xmlns:r="http://schemas.openxmlformats.org/officeDocument/2006/relationships" xmlns:p="http://schemas.openxmlformats.org/presentationml/2006/main">
   <p:cSld>
     <p:spTree>
       <p:nvGrpSpPr>
@@ -9188,7 +9479,14 @@
         <p:cNvGrpSpPr/>
         <p:nvPr/>
       </p:nvGrpSpPr>
-      <p:grpSpPr/>
+      <p:grpSpPr>
+        <a:xfrm>
+          <a:off x="0" y="0"/>
+          <a:ext cx="0" cy="0"/>
+          <a:chOff x="0" y="0"/>
+          <a:chExt cx="0" cy="0"/>
+        </a:xfrm>
+      </p:grpSpPr>
       <p:sp>
         <p:nvSpPr>
           <p:cNvPr id="2" name="Rectangle 1"/>
@@ -9229,6 +9527,7 @@
           <a:lstStyle/>
           <a:p>
             <a:pPr algn="ctr"/>
+            <a:endParaRPr/>
           </a:p>
         </p:txBody>
       </p:sp>
@@ -9272,6 +9571,7 @@
           <a:lstStyle/>
           <a:p>
             <a:pPr algn="ctr"/>
+            <a:endParaRPr/>
           </a:p>
         </p:txBody>
       </p:sp>
@@ -9529,7 +9829,7 @@
 </file>
 
 <file path=ppt/slides/slide26.xml><?xml version="1.0" encoding="utf-8"?>
-<p:sld xmlns:a="http://schemas.openxmlformats.org/drawingml/2006/main" xmlns:p="http://schemas.openxmlformats.org/presentationml/2006/main" xmlns:r="http://schemas.openxmlformats.org/officeDocument/2006/relationships">
+<p:sld xmlns:a="http://schemas.openxmlformats.org/drawingml/2006/main" xmlns:r="http://schemas.openxmlformats.org/officeDocument/2006/relationships" xmlns:p="http://schemas.openxmlformats.org/presentationml/2006/main">
   <p:cSld>
     <p:spTree>
       <p:nvGrpSpPr>
@@ -9537,7 +9837,14 @@
         <p:cNvGrpSpPr/>
         <p:nvPr/>
       </p:nvGrpSpPr>
-      <p:grpSpPr/>
+      <p:grpSpPr>
+        <a:xfrm>
+          <a:off x="0" y="0"/>
+          <a:ext cx="0" cy="0"/>
+          <a:chOff x="0" y="0"/>
+          <a:chExt cx="0" cy="0"/>
+        </a:xfrm>
+      </p:grpSpPr>
       <p:sp>
         <p:nvSpPr>
           <p:cNvPr id="2" name="Rectangle 1"/>
@@ -9578,6 +9885,7 @@
           <a:lstStyle/>
           <a:p>
             <a:pPr algn="ctr"/>
+            <a:endParaRPr/>
           </a:p>
         </p:txBody>
       </p:sp>
@@ -9621,6 +9929,7 @@
           <a:lstStyle/>
           <a:p>
             <a:pPr algn="ctr"/>
+            <a:endParaRPr/>
           </a:p>
         </p:txBody>
       </p:sp>
@@ -9859,7 +10168,7 @@
 </file>
 
 <file path=ppt/slides/slide27.xml><?xml version="1.0" encoding="utf-8"?>
-<p:sld xmlns:a="http://schemas.openxmlformats.org/drawingml/2006/main" xmlns:p="http://schemas.openxmlformats.org/presentationml/2006/main" xmlns:r="http://schemas.openxmlformats.org/officeDocument/2006/relationships">
+<p:sld xmlns:a="http://schemas.openxmlformats.org/drawingml/2006/main" xmlns:r="http://schemas.openxmlformats.org/officeDocument/2006/relationships" xmlns:p="http://schemas.openxmlformats.org/presentationml/2006/main">
   <p:cSld>
     <p:spTree>
       <p:nvGrpSpPr>
@@ -9867,7 +10176,14 @@
         <p:cNvGrpSpPr/>
         <p:nvPr/>
       </p:nvGrpSpPr>
-      <p:grpSpPr/>
+      <p:grpSpPr>
+        <a:xfrm>
+          <a:off x="0" y="0"/>
+          <a:ext cx="0" cy="0"/>
+          <a:chOff x="0" y="0"/>
+          <a:chExt cx="0" cy="0"/>
+        </a:xfrm>
+      </p:grpSpPr>
       <p:sp>
         <p:nvSpPr>
           <p:cNvPr id="2" name="Rectangle 1"/>
@@ -9908,6 +10224,7 @@
           <a:lstStyle/>
           <a:p>
             <a:pPr algn="ctr"/>
+            <a:endParaRPr/>
           </a:p>
         </p:txBody>
       </p:sp>
@@ -9951,6 +10268,7 @@
           <a:lstStyle/>
           <a:p>
             <a:pPr algn="ctr"/>
+            <a:endParaRPr/>
           </a:p>
         </p:txBody>
       </p:sp>
@@ -10008,8 +10326,20 @@
                 <a:tableStyleId>{5C22544A-7EE6-4342-B048-85BDC9FD1C3A}</a:tableStyleId>
               </a:tblPr>
               <a:tblGrid>
-                <a:gridCol w="4023360"/>
-                <a:gridCol w="4023360"/>
+                <a:gridCol w="4023360">
+                  <a:extLst>
+                    <a:ext uri="{9D8B030D-6E8A-4147-A177-3AD203B41FA5}">
+                      <a16:colId xmlns:a16="http://schemas.microsoft.com/office/drawing/2014/main" val="20000"/>
+                    </a:ext>
+                  </a:extLst>
+                </a:gridCol>
+                <a:gridCol w="4023360">
+                  <a:extLst>
+                    <a:ext uri="{9D8B030D-6E8A-4147-A177-3AD203B41FA5}">
+                      <a16:colId xmlns:a16="http://schemas.microsoft.com/office/drawing/2014/main" val="20001"/>
+                    </a:ext>
+                  </a:extLst>
+                </a:gridCol>
               </a:tblGrid>
               <a:tr h="679268">
                 <a:tc>
@@ -10058,6 +10388,11 @@
                     </a:solidFill>
                   </a:tcPr>
                 </a:tc>
+                <a:extLst>
+                  <a:ext uri="{0D108BD9-81ED-4DB2-BD59-A6C34878D82A}">
+                    <a16:rowId xmlns:a16="http://schemas.microsoft.com/office/drawing/2014/main" val="10000"/>
+                  </a:ext>
+                </a:extLst>
               </a:tr>
               <a:tr h="679268">
                 <a:tc>
@@ -10106,6 +10441,11 @@
                     </a:solidFill>
                   </a:tcPr>
                 </a:tc>
+                <a:extLst>
+                  <a:ext uri="{0D108BD9-81ED-4DB2-BD59-A6C34878D82A}">
+                    <a16:rowId xmlns:a16="http://schemas.microsoft.com/office/drawing/2014/main" val="10001"/>
+                  </a:ext>
+                </a:extLst>
               </a:tr>
               <a:tr h="679268">
                 <a:tc>
@@ -10154,6 +10494,11 @@
                     </a:solidFill>
                   </a:tcPr>
                 </a:tc>
+                <a:extLst>
+                  <a:ext uri="{0D108BD9-81ED-4DB2-BD59-A6C34878D82A}">
+                    <a16:rowId xmlns:a16="http://schemas.microsoft.com/office/drawing/2014/main" val="10002"/>
+                  </a:ext>
+                </a:extLst>
               </a:tr>
               <a:tr h="679268">
                 <a:tc>
@@ -10202,6 +10547,11 @@
                     </a:solidFill>
                   </a:tcPr>
                 </a:tc>
+                <a:extLst>
+                  <a:ext uri="{0D108BD9-81ED-4DB2-BD59-A6C34878D82A}">
+                    <a16:rowId xmlns:a16="http://schemas.microsoft.com/office/drawing/2014/main" val="10003"/>
+                  </a:ext>
+                </a:extLst>
               </a:tr>
               <a:tr h="679268">
                 <a:tc>
@@ -10250,6 +10600,11 @@
                     </a:solidFill>
                   </a:tcPr>
                 </a:tc>
+                <a:extLst>
+                  <a:ext uri="{0D108BD9-81ED-4DB2-BD59-A6C34878D82A}">
+                    <a16:rowId xmlns:a16="http://schemas.microsoft.com/office/drawing/2014/main" val="10004"/>
+                  </a:ext>
+                </a:extLst>
               </a:tr>
               <a:tr h="679268">
                 <a:tc>
@@ -10298,6 +10653,11 @@
                     </a:solidFill>
                   </a:tcPr>
                 </a:tc>
+                <a:extLst>
+                  <a:ext uri="{0D108BD9-81ED-4DB2-BD59-A6C34878D82A}">
+                    <a16:rowId xmlns:a16="http://schemas.microsoft.com/office/drawing/2014/main" val="10005"/>
+                  </a:ext>
+                </a:extLst>
               </a:tr>
               <a:tr h="679272">
                 <a:tc>
@@ -10346,6 +10706,11 @@
                     </a:solidFill>
                   </a:tcPr>
                 </a:tc>
+                <a:extLst>
+                  <a:ext uri="{0D108BD9-81ED-4DB2-BD59-A6C34878D82A}">
+                    <a16:rowId xmlns:a16="http://schemas.microsoft.com/office/drawing/2014/main" val="10006"/>
+                  </a:ext>
+                </a:extLst>
               </a:tr>
             </a:tbl>
           </a:graphicData>
@@ -10395,7 +10760,7 @@
 </file>
 
 <file path=ppt/slides/slide28.xml><?xml version="1.0" encoding="utf-8"?>
-<p:sld xmlns:a="http://schemas.openxmlformats.org/drawingml/2006/main" xmlns:p="http://schemas.openxmlformats.org/presentationml/2006/main" xmlns:r="http://schemas.openxmlformats.org/officeDocument/2006/relationships">
+<p:sld xmlns:a="http://schemas.openxmlformats.org/drawingml/2006/main" xmlns:r="http://schemas.openxmlformats.org/officeDocument/2006/relationships" xmlns:p="http://schemas.openxmlformats.org/presentationml/2006/main">
   <p:cSld>
     <p:spTree>
       <p:nvGrpSpPr>
@@ -10403,7 +10768,14 @@
         <p:cNvGrpSpPr/>
         <p:nvPr/>
       </p:nvGrpSpPr>
-      <p:grpSpPr/>
+      <p:grpSpPr>
+        <a:xfrm>
+          <a:off x="0" y="0"/>
+          <a:ext cx="0" cy="0"/>
+          <a:chOff x="0" y="0"/>
+          <a:chExt cx="0" cy="0"/>
+        </a:xfrm>
+      </p:grpSpPr>
       <p:sp>
         <p:nvSpPr>
           <p:cNvPr id="2" name="Rectangle 1"/>
@@ -10444,6 +10816,7 @@
           <a:lstStyle/>
           <a:p>
             <a:pPr algn="ctr"/>
+            <a:endParaRPr/>
           </a:p>
         </p:txBody>
       </p:sp>
@@ -10487,6 +10860,7 @@
           <a:lstStyle/>
           <a:p>
             <a:pPr algn="ctr"/>
+            <a:endParaRPr/>
           </a:p>
         </p:txBody>
       </p:sp>
@@ -10687,7 +11061,7 @@
 </file>
 
 <file path=ppt/slides/slide29.xml><?xml version="1.0" encoding="utf-8"?>
-<p:sld xmlns:a="http://schemas.openxmlformats.org/drawingml/2006/main" xmlns:p="http://schemas.openxmlformats.org/presentationml/2006/main" xmlns:r="http://schemas.openxmlformats.org/officeDocument/2006/relationships">
+<p:sld xmlns:a="http://schemas.openxmlformats.org/drawingml/2006/main" xmlns:r="http://schemas.openxmlformats.org/officeDocument/2006/relationships" xmlns:p="http://schemas.openxmlformats.org/presentationml/2006/main">
   <p:cSld>
     <p:spTree>
       <p:nvGrpSpPr>
@@ -10695,7 +11069,14 @@
         <p:cNvGrpSpPr/>
         <p:nvPr/>
       </p:nvGrpSpPr>
-      <p:grpSpPr/>
+      <p:grpSpPr>
+        <a:xfrm>
+          <a:off x="0" y="0"/>
+          <a:ext cx="0" cy="0"/>
+          <a:chOff x="0" y="0"/>
+          <a:chExt cx="0" cy="0"/>
+        </a:xfrm>
+      </p:grpSpPr>
       <p:sp>
         <p:nvSpPr>
           <p:cNvPr id="2" name="Rectangle 1"/>
@@ -10736,6 +11117,7 @@
           <a:lstStyle/>
           <a:p>
             <a:pPr algn="ctr"/>
+            <a:endParaRPr/>
           </a:p>
         </p:txBody>
       </p:sp>
@@ -10779,6 +11161,7 @@
           <a:lstStyle/>
           <a:p>
             <a:pPr algn="ctr"/>
+            <a:endParaRPr/>
           </a:p>
         </p:txBody>
       </p:sp>
@@ -10826,7 +11209,7 @@
 </file>
 
 <file path=ppt/slides/slide3.xml><?xml version="1.0" encoding="utf-8"?>
-<p:sld xmlns:a="http://schemas.openxmlformats.org/drawingml/2006/main" xmlns:p="http://schemas.openxmlformats.org/presentationml/2006/main" xmlns:r="http://schemas.openxmlformats.org/officeDocument/2006/relationships">
+<p:sld xmlns:a="http://schemas.openxmlformats.org/drawingml/2006/main" xmlns:r="http://schemas.openxmlformats.org/officeDocument/2006/relationships" xmlns:p="http://schemas.openxmlformats.org/presentationml/2006/main">
   <p:cSld>
     <p:spTree>
       <p:nvGrpSpPr>
@@ -10834,7 +11217,14 @@
         <p:cNvGrpSpPr/>
         <p:nvPr/>
       </p:nvGrpSpPr>
-      <p:grpSpPr/>
+      <p:grpSpPr>
+        <a:xfrm>
+          <a:off x="0" y="0"/>
+          <a:ext cx="0" cy="0"/>
+          <a:chOff x="0" y="0"/>
+          <a:chExt cx="0" cy="0"/>
+        </a:xfrm>
+      </p:grpSpPr>
       <p:sp>
         <p:nvSpPr>
           <p:cNvPr id="2" name="Rectangle 1"/>
@@ -10875,6 +11265,7 @@
           <a:lstStyle/>
           <a:p>
             <a:pPr algn="ctr"/>
+            <a:endParaRPr/>
           </a:p>
         </p:txBody>
       </p:sp>
@@ -10918,6 +11309,7 @@
           <a:lstStyle/>
           <a:p>
             <a:pPr algn="ctr"/>
+            <a:endParaRPr/>
           </a:p>
         </p:txBody>
       </p:sp>
@@ -10965,7 +11357,7 @@
 </file>
 
 <file path=ppt/slides/slide30.xml><?xml version="1.0" encoding="utf-8"?>
-<p:sld xmlns:a="http://schemas.openxmlformats.org/drawingml/2006/main" xmlns:p="http://schemas.openxmlformats.org/presentationml/2006/main" xmlns:r="http://schemas.openxmlformats.org/officeDocument/2006/relationships">
+<p:sld xmlns:a="http://schemas.openxmlformats.org/drawingml/2006/main" xmlns:r="http://schemas.openxmlformats.org/officeDocument/2006/relationships" xmlns:p="http://schemas.openxmlformats.org/presentationml/2006/main">
   <p:cSld>
     <p:spTree>
       <p:nvGrpSpPr>
@@ -10973,7 +11365,14 @@
         <p:cNvGrpSpPr/>
         <p:nvPr/>
       </p:nvGrpSpPr>
-      <p:grpSpPr/>
+      <p:grpSpPr>
+        <a:xfrm>
+          <a:off x="0" y="0"/>
+          <a:ext cx="0" cy="0"/>
+          <a:chOff x="0" y="0"/>
+          <a:chExt cx="0" cy="0"/>
+        </a:xfrm>
+      </p:grpSpPr>
       <p:sp>
         <p:nvSpPr>
           <p:cNvPr id="2" name="Rectangle 1"/>
@@ -11014,6 +11413,7 @@
           <a:lstStyle/>
           <a:p>
             <a:pPr algn="ctr"/>
+            <a:endParaRPr/>
           </a:p>
         </p:txBody>
       </p:sp>
@@ -11057,6 +11457,7 @@
           <a:lstStyle/>
           <a:p>
             <a:pPr algn="ctr"/>
+            <a:endParaRPr/>
           </a:p>
         </p:txBody>
       </p:sp>
@@ -11101,10 +11502,16 @@
           <p:cNvGraphicFramePr>
             <a:graphicFrameLocks noGrp="1"/>
           </p:cNvGraphicFramePr>
-          <p:nvPr/>
+          <p:nvPr>
+            <p:extLst>
+              <p:ext uri="{D42A27DB-BD31-4B8C-83A1-F6EECF244321}">
+                <p14:modId xmlns:p14="http://schemas.microsoft.com/office/powerpoint/2010/main" val="2954176002"/>
+              </p:ext>
+            </p:extLst>
+          </p:nvPr>
         </p:nvGraphicFramePr>
         <p:xfrm>
-          <a:off x="548640" y="1508760"/>
+          <a:off x="330638" y="1691640"/>
           <a:ext cx="8046720" cy="4754880"/>
         </p:xfrm>
         <a:graphic>
@@ -11114,9 +11521,27 @@
                 <a:tableStyleId>{5C22544A-7EE6-4342-B048-85BDC9FD1C3A}</a:tableStyleId>
               </a:tblPr>
               <a:tblGrid>
-                <a:gridCol w="2682240"/>
-                <a:gridCol w="2682240"/>
-                <a:gridCol w="2682240"/>
+                <a:gridCol w="2682240">
+                  <a:extLst>
+                    <a:ext uri="{9D8B030D-6E8A-4147-A177-3AD203B41FA5}">
+                      <a16:colId xmlns:a16="http://schemas.microsoft.com/office/drawing/2014/main" val="20000"/>
+                    </a:ext>
+                  </a:extLst>
+                </a:gridCol>
+                <a:gridCol w="2682240">
+                  <a:extLst>
+                    <a:ext uri="{9D8B030D-6E8A-4147-A177-3AD203B41FA5}">
+                      <a16:colId xmlns:a16="http://schemas.microsoft.com/office/drawing/2014/main" val="20001"/>
+                    </a:ext>
+                  </a:extLst>
+                </a:gridCol>
+                <a:gridCol w="2682240">
+                  <a:extLst>
+                    <a:ext uri="{9D8B030D-6E8A-4147-A177-3AD203B41FA5}">
+                      <a16:colId xmlns:a16="http://schemas.microsoft.com/office/drawing/2014/main" val="20002"/>
+                    </a:ext>
+                  </a:extLst>
+                </a:gridCol>
               </a:tblGrid>
               <a:tr h="679268">
                 <a:tc>
@@ -11126,7 +11551,7 @@
                     <a:p>
                       <a:pPr algn="ctr"/>
                       <a:r>
-                        <a:rPr sz="1800" b="1">
+                        <a:rPr sz="1800" b="1" dirty="0" err="1">
                           <a:solidFill>
                             <a:srgbClr val="FFFFFF"/>
                           </a:solidFill>
@@ -11134,6 +11559,12 @@
                         </a:rPr>
                         <a:t>维度</a:t>
                       </a:r>
+                      <a:endParaRPr sz="1800" b="1" dirty="0">
+                        <a:solidFill>
+                          <a:srgbClr val="FFFFFF"/>
+                        </a:solidFill>
+                        <a:latin typeface="微软雅黑"/>
+                      </a:endParaRPr>
                     </a:p>
                   </a:txBody>
                   <a:tcPr anchor="ctr">
@@ -11188,6 +11619,11 @@
                     </a:solidFill>
                   </a:tcPr>
                 </a:tc>
+                <a:extLst>
+                  <a:ext uri="{0D108BD9-81ED-4DB2-BD59-A6C34878D82A}">
+                    <a16:rowId xmlns:a16="http://schemas.microsoft.com/office/drawing/2014/main" val="10000"/>
+                  </a:ext>
+                </a:extLst>
               </a:tr>
               <a:tr h="679268">
                 <a:tc>
@@ -11259,6 +11695,11 @@
                     </a:solidFill>
                   </a:tcPr>
                 </a:tc>
+                <a:extLst>
+                  <a:ext uri="{0D108BD9-81ED-4DB2-BD59-A6C34878D82A}">
+                    <a16:rowId xmlns:a16="http://schemas.microsoft.com/office/drawing/2014/main" val="10001"/>
+                  </a:ext>
+                </a:extLst>
               </a:tr>
               <a:tr h="679268">
                 <a:tc>
@@ -11330,6 +11771,11 @@
                     </a:solidFill>
                   </a:tcPr>
                 </a:tc>
+                <a:extLst>
+                  <a:ext uri="{0D108BD9-81ED-4DB2-BD59-A6C34878D82A}">
+                    <a16:rowId xmlns:a16="http://schemas.microsoft.com/office/drawing/2014/main" val="10002"/>
+                  </a:ext>
+                </a:extLst>
               </a:tr>
               <a:tr h="679268">
                 <a:tc>
@@ -11401,6 +11847,11 @@
                     </a:solidFill>
                   </a:tcPr>
                 </a:tc>
+                <a:extLst>
+                  <a:ext uri="{0D108BD9-81ED-4DB2-BD59-A6C34878D82A}">
+                    <a16:rowId xmlns:a16="http://schemas.microsoft.com/office/drawing/2014/main" val="10003"/>
+                  </a:ext>
+                </a:extLst>
               </a:tr>
               <a:tr h="679268">
                 <a:tc>
@@ -11472,6 +11923,11 @@
                     </a:solidFill>
                   </a:tcPr>
                 </a:tc>
+                <a:extLst>
+                  <a:ext uri="{0D108BD9-81ED-4DB2-BD59-A6C34878D82A}">
+                    <a16:rowId xmlns:a16="http://schemas.microsoft.com/office/drawing/2014/main" val="10004"/>
+                  </a:ext>
+                </a:extLst>
               </a:tr>
               <a:tr h="679268">
                 <a:tc>
@@ -11543,6 +11999,11 @@
                     </a:solidFill>
                   </a:tcPr>
                 </a:tc>
+                <a:extLst>
+                  <a:ext uri="{0D108BD9-81ED-4DB2-BD59-A6C34878D82A}">
+                    <a16:rowId xmlns:a16="http://schemas.microsoft.com/office/drawing/2014/main" val="10005"/>
+                  </a:ext>
+                </a:extLst>
               </a:tr>
               <a:tr h="679272">
                 <a:tc>
@@ -11598,7 +12059,7 @@
                     <a:p>
                       <a:pPr algn="ctr"/>
                       <a:r>
-                        <a:rPr sz="1600" b="0">
+                        <a:rPr sz="1600" b="0" dirty="0" err="1">
                           <a:solidFill>
                             <a:srgbClr val="1A1A1A"/>
                           </a:solidFill>
@@ -11606,6 +12067,12 @@
                         </a:rPr>
                         <a:t>Sink→传感器，通常数据包可靠</a:t>
                       </a:r>
+                      <a:endParaRPr sz="1600" b="0" dirty="0">
+                        <a:solidFill>
+                          <a:srgbClr val="1A1A1A"/>
+                        </a:solidFill>
+                        <a:latin typeface="微软雅黑"/>
+                      </a:endParaRPr>
                     </a:p>
                   </a:txBody>
                   <a:tcPr anchor="ctr">
@@ -11614,6 +12081,11 @@
                     </a:solidFill>
                   </a:tcPr>
                 </a:tc>
+                <a:extLst>
+                  <a:ext uri="{0D108BD9-81ED-4DB2-BD59-A6C34878D82A}">
+                    <a16:rowId xmlns:a16="http://schemas.microsoft.com/office/drawing/2014/main" val="10006"/>
+                  </a:ext>
+                </a:extLst>
               </a:tr>
             </a:tbl>
           </a:graphicData>
@@ -11663,7 +12135,7 @@
 </file>
 
 <file path=ppt/slides/slide31.xml><?xml version="1.0" encoding="utf-8"?>
-<p:sld xmlns:a="http://schemas.openxmlformats.org/drawingml/2006/main" xmlns:p="http://schemas.openxmlformats.org/presentationml/2006/main" xmlns:r="http://schemas.openxmlformats.org/officeDocument/2006/relationships">
+<p:sld xmlns:a="http://schemas.openxmlformats.org/drawingml/2006/main" xmlns:r="http://schemas.openxmlformats.org/officeDocument/2006/relationships" xmlns:p="http://schemas.openxmlformats.org/presentationml/2006/main">
   <p:cSld>
     <p:spTree>
       <p:nvGrpSpPr>
@@ -11671,7 +12143,14 @@
         <p:cNvGrpSpPr/>
         <p:nvPr/>
       </p:nvGrpSpPr>
-      <p:grpSpPr/>
+      <p:grpSpPr>
+        <a:xfrm>
+          <a:off x="0" y="0"/>
+          <a:ext cx="0" cy="0"/>
+          <a:chOff x="0" y="0"/>
+          <a:chExt cx="0" cy="0"/>
+        </a:xfrm>
+      </p:grpSpPr>
       <p:sp>
         <p:nvSpPr>
           <p:cNvPr id="2" name="Rectangle 1"/>
@@ -11712,6 +12191,7 @@
           <a:lstStyle/>
           <a:p>
             <a:pPr algn="ctr"/>
+            <a:endParaRPr/>
           </a:p>
         </p:txBody>
       </p:sp>
@@ -11755,6 +12235,7 @@
           <a:lstStyle/>
           <a:p>
             <a:pPr algn="ctr"/>
+            <a:endParaRPr/>
           </a:p>
         </p:txBody>
       </p:sp>
@@ -11812,9 +12293,27 @@
                 <a:tableStyleId>{5C22544A-7EE6-4342-B048-85BDC9FD1C3A}</a:tableStyleId>
               </a:tblPr>
               <a:tblGrid>
-                <a:gridCol w="2682240"/>
-                <a:gridCol w="2682240"/>
-                <a:gridCol w="2682240"/>
+                <a:gridCol w="2682240">
+                  <a:extLst>
+                    <a:ext uri="{9D8B030D-6E8A-4147-A177-3AD203B41FA5}">
+                      <a16:colId xmlns:a16="http://schemas.microsoft.com/office/drawing/2014/main" val="20000"/>
+                    </a:ext>
+                  </a:extLst>
+                </a:gridCol>
+                <a:gridCol w="2682240">
+                  <a:extLst>
+                    <a:ext uri="{9D8B030D-6E8A-4147-A177-3AD203B41FA5}">
+                      <a16:colId xmlns:a16="http://schemas.microsoft.com/office/drawing/2014/main" val="20001"/>
+                    </a:ext>
+                  </a:extLst>
+                </a:gridCol>
+                <a:gridCol w="2682240">
+                  <a:extLst>
+                    <a:ext uri="{9D8B030D-6E8A-4147-A177-3AD203B41FA5}">
+                      <a16:colId xmlns:a16="http://schemas.microsoft.com/office/drawing/2014/main" val="20002"/>
+                    </a:ext>
+                  </a:extLst>
+                </a:gridCol>
               </a:tblGrid>
               <a:tr h="950976">
                 <a:tc>
@@ -11886,6 +12385,11 @@
                     </a:solidFill>
                   </a:tcPr>
                 </a:tc>
+                <a:extLst>
+                  <a:ext uri="{0D108BD9-81ED-4DB2-BD59-A6C34878D82A}">
+                    <a16:rowId xmlns:a16="http://schemas.microsoft.com/office/drawing/2014/main" val="10000"/>
+                  </a:ext>
+                </a:extLst>
               </a:tr>
               <a:tr h="950976">
                 <a:tc>
@@ -11957,6 +12461,11 @@
                     </a:solidFill>
                   </a:tcPr>
                 </a:tc>
+                <a:extLst>
+                  <a:ext uri="{0D108BD9-81ED-4DB2-BD59-A6C34878D82A}">
+                    <a16:rowId xmlns:a16="http://schemas.microsoft.com/office/drawing/2014/main" val="10001"/>
+                  </a:ext>
+                </a:extLst>
               </a:tr>
               <a:tr h="950976">
                 <a:tc>
@@ -12028,6 +12537,11 @@
                     </a:solidFill>
                   </a:tcPr>
                 </a:tc>
+                <a:extLst>
+                  <a:ext uri="{0D108BD9-81ED-4DB2-BD59-A6C34878D82A}">
+                    <a16:rowId xmlns:a16="http://schemas.microsoft.com/office/drawing/2014/main" val="10002"/>
+                  </a:ext>
+                </a:extLst>
               </a:tr>
               <a:tr h="950976">
                 <a:tc>
@@ -12099,6 +12613,11 @@
                     </a:solidFill>
                   </a:tcPr>
                 </a:tc>
+                <a:extLst>
+                  <a:ext uri="{0D108BD9-81ED-4DB2-BD59-A6C34878D82A}">
+                    <a16:rowId xmlns:a16="http://schemas.microsoft.com/office/drawing/2014/main" val="10003"/>
+                  </a:ext>
+                </a:extLst>
               </a:tr>
               <a:tr h="950976">
                 <a:tc>
@@ -12154,7 +12673,7 @@
                     <a:p>
                       <a:pPr algn="ctr"/>
                       <a:r>
-                        <a:rPr sz="1600" b="0">
+                        <a:rPr sz="1600" b="0" dirty="0">
                           <a:solidFill>
                             <a:srgbClr val="1A1A1A"/>
                           </a:solidFill>
@@ -12170,6 +12689,11 @@
                     </a:solidFill>
                   </a:tcPr>
                 </a:tc>
+                <a:extLst>
+                  <a:ext uri="{0D108BD9-81ED-4DB2-BD59-A6C34878D82A}">
+                    <a16:rowId xmlns:a16="http://schemas.microsoft.com/office/drawing/2014/main" val="10004"/>
+                  </a:ext>
+                </a:extLst>
               </a:tr>
             </a:tbl>
           </a:graphicData>
@@ -12219,7 +12743,7 @@
 </file>
 
 <file path=ppt/slides/slide32.xml><?xml version="1.0" encoding="utf-8"?>
-<p:sld xmlns:a="http://schemas.openxmlformats.org/drawingml/2006/main" xmlns:p="http://schemas.openxmlformats.org/presentationml/2006/main" xmlns:r="http://schemas.openxmlformats.org/officeDocument/2006/relationships">
+<p:sld xmlns:a="http://schemas.openxmlformats.org/drawingml/2006/main" xmlns:r="http://schemas.openxmlformats.org/officeDocument/2006/relationships" xmlns:p="http://schemas.openxmlformats.org/presentationml/2006/main">
   <p:cSld>
     <p:spTree>
       <p:nvGrpSpPr>
@@ -12227,7 +12751,14 @@
         <p:cNvGrpSpPr/>
         <p:nvPr/>
       </p:nvGrpSpPr>
-      <p:grpSpPr/>
+      <p:grpSpPr>
+        <a:xfrm>
+          <a:off x="0" y="0"/>
+          <a:ext cx="0" cy="0"/>
+          <a:chOff x="0" y="0"/>
+          <a:chExt cx="0" cy="0"/>
+        </a:xfrm>
+      </p:grpSpPr>
       <p:sp>
         <p:nvSpPr>
           <p:cNvPr id="2" name="Rectangle 1"/>
@@ -12268,6 +12799,7 @@
           <a:lstStyle/>
           <a:p>
             <a:pPr algn="ctr"/>
+            <a:endParaRPr/>
           </a:p>
         </p:txBody>
       </p:sp>
@@ -12311,6 +12843,7 @@
           <a:lstStyle/>
           <a:p>
             <a:pPr algn="ctr"/>
+            <a:endParaRPr/>
           </a:p>
         </p:txBody>
       </p:sp>
@@ -12368,10 +12901,34 @@
                 <a:tableStyleId>{5C22544A-7EE6-4342-B048-85BDC9FD1C3A}</a:tableStyleId>
               </a:tblPr>
               <a:tblGrid>
-                <a:gridCol w="2011680"/>
-                <a:gridCol w="2011680"/>
-                <a:gridCol w="2011680"/>
-                <a:gridCol w="2011680"/>
+                <a:gridCol w="2011680">
+                  <a:extLst>
+                    <a:ext uri="{9D8B030D-6E8A-4147-A177-3AD203B41FA5}">
+                      <a16:colId xmlns:a16="http://schemas.microsoft.com/office/drawing/2014/main" val="20000"/>
+                    </a:ext>
+                  </a:extLst>
+                </a:gridCol>
+                <a:gridCol w="2011680">
+                  <a:extLst>
+                    <a:ext uri="{9D8B030D-6E8A-4147-A177-3AD203B41FA5}">
+                      <a16:colId xmlns:a16="http://schemas.microsoft.com/office/drawing/2014/main" val="20001"/>
+                    </a:ext>
+                  </a:extLst>
+                </a:gridCol>
+                <a:gridCol w="2011680">
+                  <a:extLst>
+                    <a:ext uri="{9D8B030D-6E8A-4147-A177-3AD203B41FA5}">
+                      <a16:colId xmlns:a16="http://schemas.microsoft.com/office/drawing/2014/main" val="20002"/>
+                    </a:ext>
+                  </a:extLst>
+                </a:gridCol>
+                <a:gridCol w="2011680">
+                  <a:extLst>
+                    <a:ext uri="{9D8B030D-6E8A-4147-A177-3AD203B41FA5}">
+                      <a16:colId xmlns:a16="http://schemas.microsoft.com/office/drawing/2014/main" val="20003"/>
+                    </a:ext>
+                  </a:extLst>
+                </a:gridCol>
               </a:tblGrid>
               <a:tr h="1188720">
                 <a:tc>
@@ -12466,6 +13023,11 @@
                     </a:solidFill>
                   </a:tcPr>
                 </a:tc>
+                <a:extLst>
+                  <a:ext uri="{0D108BD9-81ED-4DB2-BD59-A6C34878D82A}">
+                    <a16:rowId xmlns:a16="http://schemas.microsoft.com/office/drawing/2014/main" val="10000"/>
+                  </a:ext>
+                </a:extLst>
               </a:tr>
               <a:tr h="1188720">
                 <a:tc>
@@ -12560,6 +13122,11 @@
                     </a:solidFill>
                   </a:tcPr>
                 </a:tc>
+                <a:extLst>
+                  <a:ext uri="{0D108BD9-81ED-4DB2-BD59-A6C34878D82A}">
+                    <a16:rowId xmlns:a16="http://schemas.microsoft.com/office/drawing/2014/main" val="10001"/>
+                  </a:ext>
+                </a:extLst>
               </a:tr>
               <a:tr h="1188720">
                 <a:tc>
@@ -12654,6 +13221,11 @@
                     </a:solidFill>
                   </a:tcPr>
                 </a:tc>
+                <a:extLst>
+                  <a:ext uri="{0D108BD9-81ED-4DB2-BD59-A6C34878D82A}">
+                    <a16:rowId xmlns:a16="http://schemas.microsoft.com/office/drawing/2014/main" val="10002"/>
+                  </a:ext>
+                </a:extLst>
               </a:tr>
               <a:tr h="1188720">
                 <a:tc>
@@ -12663,7 +13235,7 @@
                     <a:p>
                       <a:pPr algn="ctr"/>
                       <a:r>
-                        <a:rPr sz="1600" b="0">
+                        <a:rPr sz="1600" b="0" dirty="0" err="1">
                           <a:solidFill>
                             <a:srgbClr val="1A1A1A"/>
                           </a:solidFill>
@@ -12671,6 +13243,12 @@
                         </a:rPr>
                         <a:t>隐式ACK</a:t>
                       </a:r>
+                      <a:endParaRPr sz="1600" b="0" dirty="0">
+                        <a:solidFill>
+                          <a:srgbClr val="1A1A1A"/>
+                        </a:solidFill>
+                        <a:latin typeface="微软雅黑"/>
+                      </a:endParaRPr>
                     </a:p>
                   </a:txBody>
                   <a:tcPr anchor="ctr">
@@ -12732,13 +13310,31 @@
                     <a:p>
                       <a:pPr algn="ctr"/>
                       <a:r>
-                        <a:rPr sz="1600" b="0">
+                        <a:rPr sz="1600" b="0" dirty="0">
                           <a:solidFill>
                             <a:srgbClr val="1A1A1A"/>
                           </a:solidFill>
                           <a:latin typeface="微软雅黑"/>
                         </a:rPr>
-                        <a:t>低(无额外消息)</a:t>
+                        <a:t>低(</a:t>
+                      </a:r>
+                      <a:r>
+                        <a:rPr sz="1600" b="0" dirty="0" err="1">
+                          <a:solidFill>
+                            <a:srgbClr val="1A1A1A"/>
+                          </a:solidFill>
+                          <a:latin typeface="微软雅黑"/>
+                        </a:rPr>
+                        <a:t>无额外消息</a:t>
+                      </a:r>
+                      <a:r>
+                        <a:rPr sz="1600" b="0" dirty="0">
+                          <a:solidFill>
+                            <a:srgbClr val="1A1A1A"/>
+                          </a:solidFill>
+                          <a:latin typeface="微软雅黑"/>
+                        </a:rPr>
+                        <a:t>)</a:t>
                       </a:r>
                     </a:p>
                   </a:txBody>
@@ -12748,6 +13344,11 @@
                     </a:solidFill>
                   </a:tcPr>
                 </a:tc>
+                <a:extLst>
+                  <a:ext uri="{0D108BD9-81ED-4DB2-BD59-A6C34878D82A}">
+                    <a16:rowId xmlns:a16="http://schemas.microsoft.com/office/drawing/2014/main" val="10003"/>
+                  </a:ext>
+                </a:extLst>
               </a:tr>
             </a:tbl>
           </a:graphicData>
@@ -12797,7 +13398,7 @@
 </file>
 
 <file path=ppt/slides/slide33.xml><?xml version="1.0" encoding="utf-8"?>
-<p:sld xmlns:a="http://schemas.openxmlformats.org/drawingml/2006/main" xmlns:p="http://schemas.openxmlformats.org/presentationml/2006/main" xmlns:r="http://schemas.openxmlformats.org/officeDocument/2006/relationships">
+<p:sld xmlns:a="http://schemas.openxmlformats.org/drawingml/2006/main" xmlns:r="http://schemas.openxmlformats.org/officeDocument/2006/relationships" xmlns:p="http://schemas.openxmlformats.org/presentationml/2006/main">
   <p:cSld>
     <p:spTree>
       <p:nvGrpSpPr>
@@ -12805,7 +13406,14 @@
         <p:cNvGrpSpPr/>
         <p:nvPr/>
       </p:nvGrpSpPr>
-      <p:grpSpPr/>
+      <p:grpSpPr>
+        <a:xfrm>
+          <a:off x="0" y="0"/>
+          <a:ext cx="0" cy="0"/>
+          <a:chOff x="0" y="0"/>
+          <a:chExt cx="0" cy="0"/>
+        </a:xfrm>
+      </p:grpSpPr>
       <p:sp>
         <p:nvSpPr>
           <p:cNvPr id="2" name="Rectangle 1"/>
@@ -12846,6 +13454,7 @@
           <a:lstStyle/>
           <a:p>
             <a:pPr algn="ctr"/>
+            <a:endParaRPr/>
           </a:p>
         </p:txBody>
       </p:sp>
@@ -12889,6 +13498,7 @@
           <a:lstStyle/>
           <a:p>
             <a:pPr algn="ctr"/>
+            <a:endParaRPr/>
           </a:p>
         </p:txBody>
       </p:sp>
@@ -13146,7 +13756,7 @@
 </file>
 
 <file path=ppt/slides/slide34.xml><?xml version="1.0" encoding="utf-8"?>
-<p:sld xmlns:a="http://schemas.openxmlformats.org/drawingml/2006/main" xmlns:p="http://schemas.openxmlformats.org/presentationml/2006/main" xmlns:r="http://schemas.openxmlformats.org/officeDocument/2006/relationships">
+<p:sld xmlns:a="http://schemas.openxmlformats.org/drawingml/2006/main" xmlns:r="http://schemas.openxmlformats.org/officeDocument/2006/relationships" xmlns:p="http://schemas.openxmlformats.org/presentationml/2006/main">
   <p:cSld>
     <p:spTree>
       <p:nvGrpSpPr>
@@ -13154,7 +13764,14 @@
         <p:cNvGrpSpPr/>
         <p:nvPr/>
       </p:nvGrpSpPr>
-      <p:grpSpPr/>
+      <p:grpSpPr>
+        <a:xfrm>
+          <a:off x="0" y="0"/>
+          <a:ext cx="0" cy="0"/>
+          <a:chOff x="0" y="0"/>
+          <a:chExt cx="0" cy="0"/>
+        </a:xfrm>
+      </p:grpSpPr>
       <p:sp>
         <p:nvSpPr>
           <p:cNvPr id="2" name="Rectangle 1"/>
@@ -13195,6 +13812,7 @@
           <a:lstStyle/>
           <a:p>
             <a:pPr algn="ctr"/>
+            <a:endParaRPr/>
           </a:p>
         </p:txBody>
       </p:sp>
@@ -13238,6 +13856,7 @@
           <a:lstStyle/>
           <a:p>
             <a:pPr algn="ctr"/>
+            <a:endParaRPr/>
           </a:p>
         </p:txBody>
       </p:sp>
@@ -13476,7 +14095,7 @@
 </file>
 
 <file path=ppt/slides/slide35.xml><?xml version="1.0" encoding="utf-8"?>
-<p:sld xmlns:a="http://schemas.openxmlformats.org/drawingml/2006/main" xmlns:p="http://schemas.openxmlformats.org/presentationml/2006/main" xmlns:r="http://schemas.openxmlformats.org/officeDocument/2006/relationships">
+<p:sld xmlns:a="http://schemas.openxmlformats.org/drawingml/2006/main" xmlns:r="http://schemas.openxmlformats.org/officeDocument/2006/relationships" xmlns:p="http://schemas.openxmlformats.org/presentationml/2006/main">
   <p:cSld>
     <p:spTree>
       <p:nvGrpSpPr>
@@ -13484,7 +14103,14 @@
         <p:cNvGrpSpPr/>
         <p:nvPr/>
       </p:nvGrpSpPr>
-      <p:grpSpPr/>
+      <p:grpSpPr>
+        <a:xfrm>
+          <a:off x="0" y="0"/>
+          <a:ext cx="0" cy="0"/>
+          <a:chOff x="0" y="0"/>
+          <a:chExt cx="0" cy="0"/>
+        </a:xfrm>
+      </p:grpSpPr>
       <p:sp>
         <p:nvSpPr>
           <p:cNvPr id="2" name="Rectangle 1"/>
@@ -13525,6 +14151,7 @@
           <a:lstStyle/>
           <a:p>
             <a:pPr algn="ctr"/>
+            <a:endParaRPr/>
           </a:p>
         </p:txBody>
       </p:sp>
@@ -13568,6 +14195,7 @@
           <a:lstStyle/>
           <a:p>
             <a:pPr algn="ctr"/>
+            <a:endParaRPr/>
           </a:p>
         </p:txBody>
       </p:sp>
@@ -13625,10 +14253,34 @@
                 <a:tableStyleId>{5C22544A-7EE6-4342-B048-85BDC9FD1C3A}</a:tableStyleId>
               </a:tblPr>
               <a:tblGrid>
-                <a:gridCol w="2011680"/>
-                <a:gridCol w="2011680"/>
-                <a:gridCol w="2011680"/>
-                <a:gridCol w="2011680"/>
+                <a:gridCol w="2011680">
+                  <a:extLst>
+                    <a:ext uri="{9D8B030D-6E8A-4147-A177-3AD203B41FA5}">
+                      <a16:colId xmlns:a16="http://schemas.microsoft.com/office/drawing/2014/main" val="20000"/>
+                    </a:ext>
+                  </a:extLst>
+                </a:gridCol>
+                <a:gridCol w="2011680">
+                  <a:extLst>
+                    <a:ext uri="{9D8B030D-6E8A-4147-A177-3AD203B41FA5}">
+                      <a16:colId xmlns:a16="http://schemas.microsoft.com/office/drawing/2014/main" val="20001"/>
+                    </a:ext>
+                  </a:extLst>
+                </a:gridCol>
+                <a:gridCol w="2011680">
+                  <a:extLst>
+                    <a:ext uri="{9D8B030D-6E8A-4147-A177-3AD203B41FA5}">
+                      <a16:colId xmlns:a16="http://schemas.microsoft.com/office/drawing/2014/main" val="20002"/>
+                    </a:ext>
+                  </a:extLst>
+                </a:gridCol>
+                <a:gridCol w="2011680">
+                  <a:extLst>
+                    <a:ext uri="{9D8B030D-6E8A-4147-A177-3AD203B41FA5}">
+                      <a16:colId xmlns:a16="http://schemas.microsoft.com/office/drawing/2014/main" val="20003"/>
+                    </a:ext>
+                  </a:extLst>
+                </a:gridCol>
               </a:tblGrid>
               <a:tr h="792480">
                 <a:tc>
@@ -13723,6 +14375,11 @@
                     </a:solidFill>
                   </a:tcPr>
                 </a:tc>
+                <a:extLst>
+                  <a:ext uri="{0D108BD9-81ED-4DB2-BD59-A6C34878D82A}">
+                    <a16:rowId xmlns:a16="http://schemas.microsoft.com/office/drawing/2014/main" val="10000"/>
+                  </a:ext>
+                </a:extLst>
               </a:tr>
               <a:tr h="792480">
                 <a:tc>
@@ -13817,6 +14474,11 @@
                     </a:solidFill>
                   </a:tcPr>
                 </a:tc>
+                <a:extLst>
+                  <a:ext uri="{0D108BD9-81ED-4DB2-BD59-A6C34878D82A}">
+                    <a16:rowId xmlns:a16="http://schemas.microsoft.com/office/drawing/2014/main" val="10001"/>
+                  </a:ext>
+                </a:extLst>
               </a:tr>
               <a:tr h="792480">
                 <a:tc>
@@ -13911,6 +14573,11 @@
                     </a:solidFill>
                   </a:tcPr>
                 </a:tc>
+                <a:extLst>
+                  <a:ext uri="{0D108BD9-81ED-4DB2-BD59-A6C34878D82A}">
+                    <a16:rowId xmlns:a16="http://schemas.microsoft.com/office/drawing/2014/main" val="10002"/>
+                  </a:ext>
+                </a:extLst>
               </a:tr>
               <a:tr h="792480">
                 <a:tc>
@@ -14005,6 +14672,11 @@
                     </a:solidFill>
                   </a:tcPr>
                 </a:tc>
+                <a:extLst>
+                  <a:ext uri="{0D108BD9-81ED-4DB2-BD59-A6C34878D82A}">
+                    <a16:rowId xmlns:a16="http://schemas.microsoft.com/office/drawing/2014/main" val="10003"/>
+                  </a:ext>
+                </a:extLst>
               </a:tr>
               <a:tr h="792480">
                 <a:tc>
@@ -14099,6 +14771,11 @@
                     </a:solidFill>
                   </a:tcPr>
                 </a:tc>
+                <a:extLst>
+                  <a:ext uri="{0D108BD9-81ED-4DB2-BD59-A6C34878D82A}">
+                    <a16:rowId xmlns:a16="http://schemas.microsoft.com/office/drawing/2014/main" val="10004"/>
+                  </a:ext>
+                </a:extLst>
               </a:tr>
               <a:tr h="792480">
                 <a:tc>
@@ -14193,6 +14870,11 @@
                     </a:solidFill>
                   </a:tcPr>
                 </a:tc>
+                <a:extLst>
+                  <a:ext uri="{0D108BD9-81ED-4DB2-BD59-A6C34878D82A}">
+                    <a16:rowId xmlns:a16="http://schemas.microsoft.com/office/drawing/2014/main" val="10005"/>
+                  </a:ext>
+                </a:extLst>
               </a:tr>
             </a:tbl>
           </a:graphicData>
@@ -14242,7 +14924,7 @@
 </file>
 
 <file path=ppt/slides/slide36.xml><?xml version="1.0" encoding="utf-8"?>
-<p:sld xmlns:a="http://schemas.openxmlformats.org/drawingml/2006/main" xmlns:p="http://schemas.openxmlformats.org/presentationml/2006/main" xmlns:r="http://schemas.openxmlformats.org/officeDocument/2006/relationships">
+<p:sld xmlns:a="http://schemas.openxmlformats.org/drawingml/2006/main" xmlns:r="http://schemas.openxmlformats.org/officeDocument/2006/relationships" xmlns:p="http://schemas.openxmlformats.org/presentationml/2006/main">
   <p:cSld>
     <p:spTree>
       <p:nvGrpSpPr>
@@ -14250,7 +14932,14 @@
         <p:cNvGrpSpPr/>
         <p:nvPr/>
       </p:nvGrpSpPr>
-      <p:grpSpPr/>
+      <p:grpSpPr>
+        <a:xfrm>
+          <a:off x="0" y="0"/>
+          <a:ext cx="0" cy="0"/>
+          <a:chOff x="0" y="0"/>
+          <a:chExt cx="0" cy="0"/>
+        </a:xfrm>
+      </p:grpSpPr>
       <p:sp>
         <p:nvSpPr>
           <p:cNvPr id="2" name="Rectangle 1"/>
@@ -14291,6 +14980,7 @@
           <a:lstStyle/>
           <a:p>
             <a:pPr algn="ctr"/>
+            <a:endParaRPr/>
           </a:p>
         </p:txBody>
       </p:sp>
@@ -14334,6 +15024,7 @@
           <a:lstStyle/>
           <a:p>
             <a:pPr algn="ctr"/>
+            <a:endParaRPr/>
           </a:p>
         </p:txBody>
       </p:sp>
@@ -14572,7 +15263,7 @@
 </file>
 
 <file path=ppt/slides/slide37.xml><?xml version="1.0" encoding="utf-8"?>
-<p:sld xmlns:a="http://schemas.openxmlformats.org/drawingml/2006/main" xmlns:p="http://schemas.openxmlformats.org/presentationml/2006/main" xmlns:r="http://schemas.openxmlformats.org/officeDocument/2006/relationships">
+<p:sld xmlns:a="http://schemas.openxmlformats.org/drawingml/2006/main" xmlns:r="http://schemas.openxmlformats.org/officeDocument/2006/relationships" xmlns:p="http://schemas.openxmlformats.org/presentationml/2006/main">
   <p:cSld>
     <p:spTree>
       <p:nvGrpSpPr>
@@ -14580,7 +15271,14 @@
         <p:cNvGrpSpPr/>
         <p:nvPr/>
       </p:nvGrpSpPr>
-      <p:grpSpPr/>
+      <p:grpSpPr>
+        <a:xfrm>
+          <a:off x="0" y="0"/>
+          <a:ext cx="0" cy="0"/>
+          <a:chOff x="0" y="0"/>
+          <a:chExt cx="0" cy="0"/>
+        </a:xfrm>
+      </p:grpSpPr>
       <p:sp>
         <p:nvSpPr>
           <p:cNvPr id="2" name="Rectangle 1"/>
@@ -14621,6 +15319,7 @@
           <a:lstStyle/>
           <a:p>
             <a:pPr algn="ctr"/>
+            <a:endParaRPr/>
           </a:p>
         </p:txBody>
       </p:sp>
@@ -14664,6 +15363,7 @@
           <a:lstStyle/>
           <a:p>
             <a:pPr algn="ctr"/>
+            <a:endParaRPr/>
           </a:p>
         </p:txBody>
       </p:sp>
@@ -14883,7 +15583,7 @@
 </file>
 
 <file path=ppt/slides/slide38.xml><?xml version="1.0" encoding="utf-8"?>
-<p:sld xmlns:a="http://schemas.openxmlformats.org/drawingml/2006/main" xmlns:p="http://schemas.openxmlformats.org/presentationml/2006/main" xmlns:r="http://schemas.openxmlformats.org/officeDocument/2006/relationships">
+<p:sld xmlns:a="http://schemas.openxmlformats.org/drawingml/2006/main" xmlns:r="http://schemas.openxmlformats.org/officeDocument/2006/relationships" xmlns:p="http://schemas.openxmlformats.org/presentationml/2006/main">
   <p:cSld>
     <p:spTree>
       <p:nvGrpSpPr>
@@ -14891,7 +15591,14 @@
         <p:cNvGrpSpPr/>
         <p:nvPr/>
       </p:nvGrpSpPr>
-      <p:grpSpPr/>
+      <p:grpSpPr>
+        <a:xfrm>
+          <a:off x="0" y="0"/>
+          <a:ext cx="0" cy="0"/>
+          <a:chOff x="0" y="0"/>
+          <a:chExt cx="0" cy="0"/>
+        </a:xfrm>
+      </p:grpSpPr>
       <p:sp>
         <p:nvSpPr>
           <p:cNvPr id="2" name="Rectangle 1"/>
@@ -14932,6 +15639,7 @@
           <a:lstStyle/>
           <a:p>
             <a:pPr algn="ctr"/>
+            <a:endParaRPr/>
           </a:p>
         </p:txBody>
       </p:sp>
@@ -14975,6 +15683,7 @@
           <a:lstStyle/>
           <a:p>
             <a:pPr algn="ctr"/>
+            <a:endParaRPr/>
           </a:p>
         </p:txBody>
       </p:sp>
@@ -15213,7 +15922,7 @@
 </file>
 
 <file path=ppt/slides/slide39.xml><?xml version="1.0" encoding="utf-8"?>
-<p:sld xmlns:a="http://schemas.openxmlformats.org/drawingml/2006/main" xmlns:p="http://schemas.openxmlformats.org/presentationml/2006/main" xmlns:r="http://schemas.openxmlformats.org/officeDocument/2006/relationships">
+<p:sld xmlns:a="http://schemas.openxmlformats.org/drawingml/2006/main" xmlns:r="http://schemas.openxmlformats.org/officeDocument/2006/relationships" xmlns:p="http://schemas.openxmlformats.org/presentationml/2006/main">
   <p:cSld>
     <p:spTree>
       <p:nvGrpSpPr>
@@ -15221,7 +15930,14 @@
         <p:cNvGrpSpPr/>
         <p:nvPr/>
       </p:nvGrpSpPr>
-      <p:grpSpPr/>
+      <p:grpSpPr>
+        <a:xfrm>
+          <a:off x="0" y="0"/>
+          <a:ext cx="0" cy="0"/>
+          <a:chOff x="0" y="0"/>
+          <a:chExt cx="0" cy="0"/>
+        </a:xfrm>
+      </p:grpSpPr>
       <p:sp>
         <p:nvSpPr>
           <p:cNvPr id="2" name="Rectangle 1"/>
@@ -15262,6 +15978,7 @@
           <a:lstStyle/>
           <a:p>
             <a:pPr algn="ctr"/>
+            <a:endParaRPr/>
           </a:p>
         </p:txBody>
       </p:sp>
@@ -15305,6 +16022,7 @@
           <a:lstStyle/>
           <a:p>
             <a:pPr algn="ctr"/>
+            <a:endParaRPr/>
           </a:p>
         </p:txBody>
       </p:sp>
@@ -15562,7 +16280,7 @@
 </file>
 
 <file path=ppt/slides/slide4.xml><?xml version="1.0" encoding="utf-8"?>
-<p:sld xmlns:a="http://schemas.openxmlformats.org/drawingml/2006/main" xmlns:p="http://schemas.openxmlformats.org/presentationml/2006/main" xmlns:r="http://schemas.openxmlformats.org/officeDocument/2006/relationships">
+<p:sld xmlns:a="http://schemas.openxmlformats.org/drawingml/2006/main" xmlns:r="http://schemas.openxmlformats.org/officeDocument/2006/relationships" xmlns:p="http://schemas.openxmlformats.org/presentationml/2006/main">
   <p:cSld>
     <p:spTree>
       <p:nvGrpSpPr>
@@ -15570,7 +16288,14 @@
         <p:cNvGrpSpPr/>
         <p:nvPr/>
       </p:nvGrpSpPr>
-      <p:grpSpPr/>
+      <p:grpSpPr>
+        <a:xfrm>
+          <a:off x="0" y="0"/>
+          <a:ext cx="0" cy="0"/>
+          <a:chOff x="0" y="0"/>
+          <a:chExt cx="0" cy="0"/>
+        </a:xfrm>
+      </p:grpSpPr>
       <p:sp>
         <p:nvSpPr>
           <p:cNvPr id="2" name="Rectangle 1"/>
@@ -15611,6 +16336,7 @@
           <a:lstStyle/>
           <a:p>
             <a:pPr algn="ctr"/>
+            <a:endParaRPr/>
           </a:p>
         </p:txBody>
       </p:sp>
@@ -15654,6 +16380,7 @@
           <a:lstStyle/>
           <a:p>
             <a:pPr algn="ctr"/>
+            <a:endParaRPr/>
           </a:p>
         </p:txBody>
       </p:sp>
@@ -15854,7 +16581,7 @@
 </file>
 
 <file path=ppt/slides/slide40.xml><?xml version="1.0" encoding="utf-8"?>
-<p:sld xmlns:a="http://schemas.openxmlformats.org/drawingml/2006/main" xmlns:p="http://schemas.openxmlformats.org/presentationml/2006/main" xmlns:r="http://schemas.openxmlformats.org/officeDocument/2006/relationships">
+<p:sld xmlns:a="http://schemas.openxmlformats.org/drawingml/2006/main" xmlns:r="http://schemas.openxmlformats.org/officeDocument/2006/relationships" xmlns:p="http://schemas.openxmlformats.org/presentationml/2006/main">
   <p:cSld>
     <p:spTree>
       <p:nvGrpSpPr>
@@ -15862,7 +16589,14 @@
         <p:cNvGrpSpPr/>
         <p:nvPr/>
       </p:nvGrpSpPr>
-      <p:grpSpPr/>
+      <p:grpSpPr>
+        <a:xfrm>
+          <a:off x="0" y="0"/>
+          <a:ext cx="0" cy="0"/>
+          <a:chOff x="0" y="0"/>
+          <a:chExt cx="0" cy="0"/>
+        </a:xfrm>
+      </p:grpSpPr>
       <p:sp>
         <p:nvSpPr>
           <p:cNvPr id="2" name="Rectangle 1"/>
@@ -15903,6 +16637,7 @@
           <a:lstStyle/>
           <a:p>
             <a:pPr algn="ctr"/>
+            <a:endParaRPr/>
           </a:p>
         </p:txBody>
       </p:sp>
@@ -15946,6 +16681,7 @@
           <a:lstStyle/>
           <a:p>
             <a:pPr algn="ctr"/>
+            <a:endParaRPr/>
           </a:p>
         </p:txBody>
       </p:sp>
@@ -16003,10 +16739,34 @@
                 <a:tableStyleId>{5C22544A-7EE6-4342-B048-85BDC9FD1C3A}</a:tableStyleId>
               </a:tblPr>
               <a:tblGrid>
-                <a:gridCol w="2011680"/>
-                <a:gridCol w="2011680"/>
-                <a:gridCol w="2011680"/>
-                <a:gridCol w="2011680"/>
+                <a:gridCol w="2011680">
+                  <a:extLst>
+                    <a:ext uri="{9D8B030D-6E8A-4147-A177-3AD203B41FA5}">
+                      <a16:colId xmlns:a16="http://schemas.microsoft.com/office/drawing/2014/main" val="20000"/>
+                    </a:ext>
+                  </a:extLst>
+                </a:gridCol>
+                <a:gridCol w="2011680">
+                  <a:extLst>
+                    <a:ext uri="{9D8B030D-6E8A-4147-A177-3AD203B41FA5}">
+                      <a16:colId xmlns:a16="http://schemas.microsoft.com/office/drawing/2014/main" val="20001"/>
+                    </a:ext>
+                  </a:extLst>
+                </a:gridCol>
+                <a:gridCol w="2011680">
+                  <a:extLst>
+                    <a:ext uri="{9D8B030D-6E8A-4147-A177-3AD203B41FA5}">
+                      <a16:colId xmlns:a16="http://schemas.microsoft.com/office/drawing/2014/main" val="20002"/>
+                    </a:ext>
+                  </a:extLst>
+                </a:gridCol>
+                <a:gridCol w="2011680">
+                  <a:extLst>
+                    <a:ext uri="{9D8B030D-6E8A-4147-A177-3AD203B41FA5}">
+                      <a16:colId xmlns:a16="http://schemas.microsoft.com/office/drawing/2014/main" val="20003"/>
+                    </a:ext>
+                  </a:extLst>
+                </a:gridCol>
               </a:tblGrid>
               <a:tr h="679268">
                 <a:tc>
@@ -16101,6 +16861,11 @@
                     </a:solidFill>
                   </a:tcPr>
                 </a:tc>
+                <a:extLst>
+                  <a:ext uri="{0D108BD9-81ED-4DB2-BD59-A6C34878D82A}">
+                    <a16:rowId xmlns:a16="http://schemas.microsoft.com/office/drawing/2014/main" val="10000"/>
+                  </a:ext>
+                </a:extLst>
               </a:tr>
               <a:tr h="679268">
                 <a:tc>
@@ -16195,6 +16960,11 @@
                     </a:solidFill>
                   </a:tcPr>
                 </a:tc>
+                <a:extLst>
+                  <a:ext uri="{0D108BD9-81ED-4DB2-BD59-A6C34878D82A}">
+                    <a16:rowId xmlns:a16="http://schemas.microsoft.com/office/drawing/2014/main" val="10001"/>
+                  </a:ext>
+                </a:extLst>
               </a:tr>
               <a:tr h="679268">
                 <a:tc>
@@ -16289,6 +17059,11 @@
                     </a:solidFill>
                   </a:tcPr>
                 </a:tc>
+                <a:extLst>
+                  <a:ext uri="{0D108BD9-81ED-4DB2-BD59-A6C34878D82A}">
+                    <a16:rowId xmlns:a16="http://schemas.microsoft.com/office/drawing/2014/main" val="10002"/>
+                  </a:ext>
+                </a:extLst>
               </a:tr>
               <a:tr h="679268">
                 <a:tc>
@@ -16383,6 +17158,11 @@
                     </a:solidFill>
                   </a:tcPr>
                 </a:tc>
+                <a:extLst>
+                  <a:ext uri="{0D108BD9-81ED-4DB2-BD59-A6C34878D82A}">
+                    <a16:rowId xmlns:a16="http://schemas.microsoft.com/office/drawing/2014/main" val="10003"/>
+                  </a:ext>
+                </a:extLst>
               </a:tr>
               <a:tr h="679268">
                 <a:tc>
@@ -16477,6 +17257,11 @@
                     </a:solidFill>
                   </a:tcPr>
                 </a:tc>
+                <a:extLst>
+                  <a:ext uri="{0D108BD9-81ED-4DB2-BD59-A6C34878D82A}">
+                    <a16:rowId xmlns:a16="http://schemas.microsoft.com/office/drawing/2014/main" val="10004"/>
+                  </a:ext>
+                </a:extLst>
               </a:tr>
               <a:tr h="679268">
                 <a:tc>
@@ -16571,6 +17356,11 @@
                     </a:solidFill>
                   </a:tcPr>
                 </a:tc>
+                <a:extLst>
+                  <a:ext uri="{0D108BD9-81ED-4DB2-BD59-A6C34878D82A}">
+                    <a16:rowId xmlns:a16="http://schemas.microsoft.com/office/drawing/2014/main" val="10005"/>
+                  </a:ext>
+                </a:extLst>
               </a:tr>
               <a:tr h="679272">
                 <a:tc>
@@ -16665,6 +17455,11 @@
                     </a:solidFill>
                   </a:tcPr>
                 </a:tc>
+                <a:extLst>
+                  <a:ext uri="{0D108BD9-81ED-4DB2-BD59-A6C34878D82A}">
+                    <a16:rowId xmlns:a16="http://schemas.microsoft.com/office/drawing/2014/main" val="10006"/>
+                  </a:ext>
+                </a:extLst>
               </a:tr>
             </a:tbl>
           </a:graphicData>
@@ -16714,7 +17509,7 @@
 </file>
 
 <file path=ppt/slides/slide41.xml><?xml version="1.0" encoding="utf-8"?>
-<p:sld xmlns:a="http://schemas.openxmlformats.org/drawingml/2006/main" xmlns:p="http://schemas.openxmlformats.org/presentationml/2006/main" xmlns:r="http://schemas.openxmlformats.org/officeDocument/2006/relationships">
+<p:sld xmlns:a="http://schemas.openxmlformats.org/drawingml/2006/main" xmlns:r="http://schemas.openxmlformats.org/officeDocument/2006/relationships" xmlns:p="http://schemas.openxmlformats.org/presentationml/2006/main">
   <p:cSld>
     <p:spTree>
       <p:nvGrpSpPr>
@@ -16722,7 +17517,14 @@
         <p:cNvGrpSpPr/>
         <p:nvPr/>
       </p:nvGrpSpPr>
-      <p:grpSpPr/>
+      <p:grpSpPr>
+        <a:xfrm>
+          <a:off x="0" y="0"/>
+          <a:ext cx="0" cy="0"/>
+          <a:chOff x="0" y="0"/>
+          <a:chExt cx="0" cy="0"/>
+        </a:xfrm>
+      </p:grpSpPr>
       <p:sp>
         <p:nvSpPr>
           <p:cNvPr id="2" name="Rectangle 1"/>
@@ -16763,6 +17565,7 @@
           <a:lstStyle/>
           <a:p>
             <a:pPr algn="ctr"/>
+            <a:endParaRPr/>
           </a:p>
         </p:txBody>
       </p:sp>
@@ -16806,6 +17609,7 @@
           <a:lstStyle/>
           <a:p>
             <a:pPr algn="ctr"/>
+            <a:endParaRPr/>
           </a:p>
         </p:txBody>
       </p:sp>
@@ -17025,7 +17829,7 @@
 </file>
 
 <file path=ppt/slides/slide42.xml><?xml version="1.0" encoding="utf-8"?>
-<p:sld xmlns:a="http://schemas.openxmlformats.org/drawingml/2006/main" xmlns:p="http://schemas.openxmlformats.org/presentationml/2006/main" xmlns:r="http://schemas.openxmlformats.org/officeDocument/2006/relationships">
+<p:sld xmlns:a="http://schemas.openxmlformats.org/drawingml/2006/main" xmlns:r="http://schemas.openxmlformats.org/officeDocument/2006/relationships" xmlns:p="http://schemas.openxmlformats.org/presentationml/2006/main">
   <p:cSld>
     <p:spTree>
       <p:nvGrpSpPr>
@@ -17033,7 +17837,14 @@
         <p:cNvGrpSpPr/>
         <p:nvPr/>
       </p:nvGrpSpPr>
-      <p:grpSpPr/>
+      <p:grpSpPr>
+        <a:xfrm>
+          <a:off x="0" y="0"/>
+          <a:ext cx="0" cy="0"/>
+          <a:chOff x="0" y="0"/>
+          <a:chExt cx="0" cy="0"/>
+        </a:xfrm>
+      </p:grpSpPr>
       <p:sp>
         <p:nvSpPr>
           <p:cNvPr id="2" name="Rectangle 1"/>
@@ -17074,6 +17885,7 @@
           <a:lstStyle/>
           <a:p>
             <a:pPr algn="ctr"/>
+            <a:endParaRPr/>
           </a:p>
         </p:txBody>
       </p:sp>
@@ -17117,6 +17929,7 @@
           <a:lstStyle/>
           <a:p>
             <a:pPr algn="ctr"/>
+            <a:endParaRPr/>
           </a:p>
         </p:txBody>
       </p:sp>
@@ -17164,7 +17977,7 @@
 </file>
 
 <file path=ppt/slides/slide43.xml><?xml version="1.0" encoding="utf-8"?>
-<p:sld xmlns:a="http://schemas.openxmlformats.org/drawingml/2006/main" xmlns:p="http://schemas.openxmlformats.org/presentationml/2006/main" xmlns:r="http://schemas.openxmlformats.org/officeDocument/2006/relationships">
+<p:sld xmlns:a="http://schemas.openxmlformats.org/drawingml/2006/main" xmlns:r="http://schemas.openxmlformats.org/officeDocument/2006/relationships" xmlns:p="http://schemas.openxmlformats.org/presentationml/2006/main">
   <p:cSld>
     <p:spTree>
       <p:nvGrpSpPr>
@@ -17172,7 +17985,14 @@
         <p:cNvGrpSpPr/>
         <p:nvPr/>
       </p:nvGrpSpPr>
-      <p:grpSpPr/>
+      <p:grpSpPr>
+        <a:xfrm>
+          <a:off x="0" y="0"/>
+          <a:ext cx="0" cy="0"/>
+          <a:chOff x="0" y="0"/>
+          <a:chExt cx="0" cy="0"/>
+        </a:xfrm>
+      </p:grpSpPr>
       <p:sp>
         <p:nvSpPr>
           <p:cNvPr id="2" name="Rectangle 1"/>
@@ -17213,6 +18033,7 @@
           <a:lstStyle/>
           <a:p>
             <a:pPr algn="ctr"/>
+            <a:endParaRPr/>
           </a:p>
         </p:txBody>
       </p:sp>
@@ -17256,6 +18077,7 @@
           <a:lstStyle/>
           <a:p>
             <a:pPr algn="ctr"/>
+            <a:endParaRPr/>
           </a:p>
         </p:txBody>
       </p:sp>
@@ -17313,11 +18135,41 @@
                 <a:tableStyleId>{5C22544A-7EE6-4342-B048-85BDC9FD1C3A}</a:tableStyleId>
               </a:tblPr>
               <a:tblGrid>
-                <a:gridCol w="1609344"/>
-                <a:gridCol w="1609344"/>
-                <a:gridCol w="1609344"/>
-                <a:gridCol w="1609344"/>
-                <a:gridCol w="1609344"/>
+                <a:gridCol w="1609344">
+                  <a:extLst>
+                    <a:ext uri="{9D8B030D-6E8A-4147-A177-3AD203B41FA5}">
+                      <a16:colId xmlns:a16="http://schemas.microsoft.com/office/drawing/2014/main" val="20000"/>
+                    </a:ext>
+                  </a:extLst>
+                </a:gridCol>
+                <a:gridCol w="1609344">
+                  <a:extLst>
+                    <a:ext uri="{9D8B030D-6E8A-4147-A177-3AD203B41FA5}">
+                      <a16:colId xmlns:a16="http://schemas.microsoft.com/office/drawing/2014/main" val="20001"/>
+                    </a:ext>
+                  </a:extLst>
+                </a:gridCol>
+                <a:gridCol w="1609344">
+                  <a:extLst>
+                    <a:ext uri="{9D8B030D-6E8A-4147-A177-3AD203B41FA5}">
+                      <a16:colId xmlns:a16="http://schemas.microsoft.com/office/drawing/2014/main" val="20002"/>
+                    </a:ext>
+                  </a:extLst>
+                </a:gridCol>
+                <a:gridCol w="1609344">
+                  <a:extLst>
+                    <a:ext uri="{9D8B030D-6E8A-4147-A177-3AD203B41FA5}">
+                      <a16:colId xmlns:a16="http://schemas.microsoft.com/office/drawing/2014/main" val="20003"/>
+                    </a:ext>
+                  </a:extLst>
+                </a:gridCol>
+                <a:gridCol w="1609344">
+                  <a:extLst>
+                    <a:ext uri="{9D8B030D-6E8A-4147-A177-3AD203B41FA5}">
+                      <a16:colId xmlns:a16="http://schemas.microsoft.com/office/drawing/2014/main" val="20004"/>
+                    </a:ext>
+                  </a:extLst>
+                </a:gridCol>
               </a:tblGrid>
               <a:tr h="594360">
                 <a:tc>
@@ -17435,6 +18287,11 @@
                     </a:solidFill>
                   </a:tcPr>
                 </a:tc>
+                <a:extLst>
+                  <a:ext uri="{0D108BD9-81ED-4DB2-BD59-A6C34878D82A}">
+                    <a16:rowId xmlns:a16="http://schemas.microsoft.com/office/drawing/2014/main" val="10000"/>
+                  </a:ext>
+                </a:extLst>
               </a:tr>
               <a:tr h="594360">
                 <a:tc>
@@ -17552,6 +18409,11 @@
                     </a:solidFill>
                   </a:tcPr>
                 </a:tc>
+                <a:extLst>
+                  <a:ext uri="{0D108BD9-81ED-4DB2-BD59-A6C34878D82A}">
+                    <a16:rowId xmlns:a16="http://schemas.microsoft.com/office/drawing/2014/main" val="10001"/>
+                  </a:ext>
+                </a:extLst>
               </a:tr>
               <a:tr h="594360">
                 <a:tc>
@@ -17669,6 +18531,11 @@
                     </a:solidFill>
                   </a:tcPr>
                 </a:tc>
+                <a:extLst>
+                  <a:ext uri="{0D108BD9-81ED-4DB2-BD59-A6C34878D82A}">
+                    <a16:rowId xmlns:a16="http://schemas.microsoft.com/office/drawing/2014/main" val="10002"/>
+                  </a:ext>
+                </a:extLst>
               </a:tr>
               <a:tr h="594360">
                 <a:tc>
@@ -17786,6 +18653,11 @@
                     </a:solidFill>
                   </a:tcPr>
                 </a:tc>
+                <a:extLst>
+                  <a:ext uri="{0D108BD9-81ED-4DB2-BD59-A6C34878D82A}">
+                    <a16:rowId xmlns:a16="http://schemas.microsoft.com/office/drawing/2014/main" val="10003"/>
+                  </a:ext>
+                </a:extLst>
               </a:tr>
               <a:tr h="594360">
                 <a:tc>
@@ -17903,6 +18775,11 @@
                     </a:solidFill>
                   </a:tcPr>
                 </a:tc>
+                <a:extLst>
+                  <a:ext uri="{0D108BD9-81ED-4DB2-BD59-A6C34878D82A}">
+                    <a16:rowId xmlns:a16="http://schemas.microsoft.com/office/drawing/2014/main" val="10004"/>
+                  </a:ext>
+                </a:extLst>
               </a:tr>
               <a:tr h="594360">
                 <a:tc>
@@ -18020,6 +18897,11 @@
                     </a:solidFill>
                   </a:tcPr>
                 </a:tc>
+                <a:extLst>
+                  <a:ext uri="{0D108BD9-81ED-4DB2-BD59-A6C34878D82A}">
+                    <a16:rowId xmlns:a16="http://schemas.microsoft.com/office/drawing/2014/main" val="10005"/>
+                  </a:ext>
+                </a:extLst>
               </a:tr>
               <a:tr h="594360">
                 <a:tc>
@@ -18137,6 +19019,11 @@
                     </a:solidFill>
                   </a:tcPr>
                 </a:tc>
+                <a:extLst>
+                  <a:ext uri="{0D108BD9-81ED-4DB2-BD59-A6C34878D82A}">
+                    <a16:rowId xmlns:a16="http://schemas.microsoft.com/office/drawing/2014/main" val="10006"/>
+                  </a:ext>
+                </a:extLst>
               </a:tr>
               <a:tr h="594360">
                 <a:tc>
@@ -18254,6 +19141,11 @@
                     </a:solidFill>
                   </a:tcPr>
                 </a:tc>
+                <a:extLst>
+                  <a:ext uri="{0D108BD9-81ED-4DB2-BD59-A6C34878D82A}">
+                    <a16:rowId xmlns:a16="http://schemas.microsoft.com/office/drawing/2014/main" val="10007"/>
+                  </a:ext>
+                </a:extLst>
               </a:tr>
             </a:tbl>
           </a:graphicData>
@@ -18303,7 +19195,7 @@
 </file>
 
 <file path=ppt/slides/slide44.xml><?xml version="1.0" encoding="utf-8"?>
-<p:sld xmlns:a="http://schemas.openxmlformats.org/drawingml/2006/main" xmlns:p="http://schemas.openxmlformats.org/presentationml/2006/main" xmlns:r="http://schemas.openxmlformats.org/officeDocument/2006/relationships">
+<p:sld xmlns:a="http://schemas.openxmlformats.org/drawingml/2006/main" xmlns:r="http://schemas.openxmlformats.org/officeDocument/2006/relationships" xmlns:p="http://schemas.openxmlformats.org/presentationml/2006/main">
   <p:cSld>
     <p:spTree>
       <p:nvGrpSpPr>
@@ -18311,7 +19203,14 @@
         <p:cNvGrpSpPr/>
         <p:nvPr/>
       </p:nvGrpSpPr>
-      <p:grpSpPr/>
+      <p:grpSpPr>
+        <a:xfrm>
+          <a:off x="0" y="0"/>
+          <a:ext cx="0" cy="0"/>
+          <a:chOff x="0" y="0"/>
+          <a:chExt cx="0" cy="0"/>
+        </a:xfrm>
+      </p:grpSpPr>
       <p:sp>
         <p:nvSpPr>
           <p:cNvPr id="2" name="Rectangle 1"/>
@@ -18352,6 +19251,7 @@
           <a:lstStyle/>
           <a:p>
             <a:pPr algn="ctr"/>
+            <a:endParaRPr/>
           </a:p>
         </p:txBody>
       </p:sp>
@@ -18395,6 +19295,7 @@
           <a:lstStyle/>
           <a:p>
             <a:pPr algn="ctr"/>
+            <a:endParaRPr/>
           </a:p>
         </p:txBody>
       </p:sp>
@@ -18633,7 +19534,7 @@
 </file>
 
 <file path=ppt/slides/slide45.xml><?xml version="1.0" encoding="utf-8"?>
-<p:sld xmlns:a="http://schemas.openxmlformats.org/drawingml/2006/main" xmlns:p="http://schemas.openxmlformats.org/presentationml/2006/main" xmlns:r="http://schemas.openxmlformats.org/officeDocument/2006/relationships">
+<p:sld xmlns:a="http://schemas.openxmlformats.org/drawingml/2006/main" xmlns:r="http://schemas.openxmlformats.org/officeDocument/2006/relationships" xmlns:p="http://schemas.openxmlformats.org/presentationml/2006/main">
   <p:cSld>
     <p:spTree>
       <p:nvGrpSpPr>
@@ -18641,7 +19542,14 @@
         <p:cNvGrpSpPr/>
         <p:nvPr/>
       </p:nvGrpSpPr>
-      <p:grpSpPr/>
+      <p:grpSpPr>
+        <a:xfrm>
+          <a:off x="0" y="0"/>
+          <a:ext cx="0" cy="0"/>
+          <a:chOff x="0" y="0"/>
+          <a:chExt cx="0" cy="0"/>
+        </a:xfrm>
+      </p:grpSpPr>
       <p:sp>
         <p:nvSpPr>
           <p:cNvPr id="2" name="Rectangle 1"/>
@@ -18682,6 +19590,7 @@
           <a:lstStyle/>
           <a:p>
             <a:pPr algn="ctr"/>
+            <a:endParaRPr/>
           </a:p>
         </p:txBody>
       </p:sp>
@@ -18725,6 +19634,7 @@
           <a:lstStyle/>
           <a:p>
             <a:pPr algn="ctr"/>
+            <a:endParaRPr/>
           </a:p>
         </p:txBody>
       </p:sp>
@@ -18944,7 +19854,7 @@
 </file>
 
 <file path=ppt/slides/slide46.xml><?xml version="1.0" encoding="utf-8"?>
-<p:sld xmlns:a="http://schemas.openxmlformats.org/drawingml/2006/main" xmlns:p="http://schemas.openxmlformats.org/presentationml/2006/main" xmlns:r="http://schemas.openxmlformats.org/officeDocument/2006/relationships">
+<p:sld xmlns:a="http://schemas.openxmlformats.org/drawingml/2006/main" xmlns:r="http://schemas.openxmlformats.org/officeDocument/2006/relationships" xmlns:p="http://schemas.openxmlformats.org/presentationml/2006/main">
   <p:cSld>
     <p:spTree>
       <p:nvGrpSpPr>
@@ -18952,7 +19862,14 @@
         <p:cNvGrpSpPr/>
         <p:nvPr/>
       </p:nvGrpSpPr>
-      <p:grpSpPr/>
+      <p:grpSpPr>
+        <a:xfrm>
+          <a:off x="0" y="0"/>
+          <a:ext cx="0" cy="0"/>
+          <a:chOff x="0" y="0"/>
+          <a:chExt cx="0" cy="0"/>
+        </a:xfrm>
+      </p:grpSpPr>
       <p:sp>
         <p:nvSpPr>
           <p:cNvPr id="2" name="Rectangle 1"/>
@@ -18993,6 +19910,7 @@
           <a:lstStyle/>
           <a:p>
             <a:pPr algn="ctr"/>
+            <a:endParaRPr/>
           </a:p>
         </p:txBody>
       </p:sp>
@@ -19036,6 +19954,7 @@
           <a:lstStyle/>
           <a:p>
             <a:pPr algn="ctr"/>
+            <a:endParaRPr/>
           </a:p>
         </p:txBody>
       </p:sp>
@@ -19255,7 +20174,7 @@
 </file>
 
 <file path=ppt/slides/slide47.xml><?xml version="1.0" encoding="utf-8"?>
-<p:sld xmlns:a="http://schemas.openxmlformats.org/drawingml/2006/main" xmlns:p="http://schemas.openxmlformats.org/presentationml/2006/main" xmlns:r="http://schemas.openxmlformats.org/officeDocument/2006/relationships">
+<p:sld xmlns:a="http://schemas.openxmlformats.org/drawingml/2006/main" xmlns:r="http://schemas.openxmlformats.org/officeDocument/2006/relationships" xmlns:p="http://schemas.openxmlformats.org/presentationml/2006/main">
   <p:cSld>
     <p:spTree>
       <p:nvGrpSpPr>
@@ -19263,7 +20182,14 @@
         <p:cNvGrpSpPr/>
         <p:nvPr/>
       </p:nvGrpSpPr>
-      <p:grpSpPr/>
+      <p:grpSpPr>
+        <a:xfrm>
+          <a:off x="0" y="0"/>
+          <a:ext cx="0" cy="0"/>
+          <a:chOff x="0" y="0"/>
+          <a:chExt cx="0" cy="0"/>
+        </a:xfrm>
+      </p:grpSpPr>
       <p:sp>
         <p:nvSpPr>
           <p:cNvPr id="2" name="Rectangle 1"/>
@@ -19304,6 +20230,7 @@
           <a:lstStyle/>
           <a:p>
             <a:pPr algn="ctr"/>
+            <a:endParaRPr/>
           </a:p>
         </p:txBody>
       </p:sp>
@@ -19347,6 +20274,7 @@
           <a:lstStyle/>
           <a:p>
             <a:pPr algn="ctr"/>
+            <a:endParaRPr/>
           </a:p>
         </p:txBody>
       </p:sp>
@@ -19429,7 +20357,7 @@
 </file>
 
 <file path=ppt/slides/slide5.xml><?xml version="1.0" encoding="utf-8"?>
-<p:sld xmlns:a="http://schemas.openxmlformats.org/drawingml/2006/main" xmlns:p="http://schemas.openxmlformats.org/presentationml/2006/main" xmlns:r="http://schemas.openxmlformats.org/officeDocument/2006/relationships">
+<p:sld xmlns:a="http://schemas.openxmlformats.org/drawingml/2006/main" xmlns:r="http://schemas.openxmlformats.org/officeDocument/2006/relationships" xmlns:p="http://schemas.openxmlformats.org/presentationml/2006/main">
   <p:cSld>
     <p:spTree>
       <p:nvGrpSpPr>
@@ -19437,7 +20365,14 @@
         <p:cNvGrpSpPr/>
         <p:nvPr/>
       </p:nvGrpSpPr>
-      <p:grpSpPr/>
+      <p:grpSpPr>
+        <a:xfrm>
+          <a:off x="0" y="0"/>
+          <a:ext cx="0" cy="0"/>
+          <a:chOff x="0" y="0"/>
+          <a:chExt cx="0" cy="0"/>
+        </a:xfrm>
+      </p:grpSpPr>
       <p:sp>
         <p:nvSpPr>
           <p:cNvPr id="2" name="Rectangle 1"/>
@@ -19478,6 +20413,7 @@
           <a:lstStyle/>
           <a:p>
             <a:pPr algn="ctr"/>
+            <a:endParaRPr/>
           </a:p>
         </p:txBody>
       </p:sp>
@@ -19521,6 +20457,7 @@
           <a:lstStyle/>
           <a:p>
             <a:pPr algn="ctr"/>
+            <a:endParaRPr/>
           </a:p>
         </p:txBody>
       </p:sp>
@@ -19740,7 +20677,7 @@
 </file>
 
 <file path=ppt/slides/slide6.xml><?xml version="1.0" encoding="utf-8"?>
-<p:sld xmlns:a="http://schemas.openxmlformats.org/drawingml/2006/main" xmlns:p="http://schemas.openxmlformats.org/presentationml/2006/main" xmlns:r="http://schemas.openxmlformats.org/officeDocument/2006/relationships">
+<p:sld xmlns:a="http://schemas.openxmlformats.org/drawingml/2006/main" xmlns:r="http://schemas.openxmlformats.org/officeDocument/2006/relationships" xmlns:p="http://schemas.openxmlformats.org/presentationml/2006/main">
   <p:cSld>
     <p:spTree>
       <p:nvGrpSpPr>
@@ -19748,7 +20685,14 @@
         <p:cNvGrpSpPr/>
         <p:nvPr/>
       </p:nvGrpSpPr>
-      <p:grpSpPr/>
+      <p:grpSpPr>
+        <a:xfrm>
+          <a:off x="0" y="0"/>
+          <a:ext cx="0" cy="0"/>
+          <a:chOff x="0" y="0"/>
+          <a:chExt cx="0" cy="0"/>
+        </a:xfrm>
+      </p:grpSpPr>
       <p:sp>
         <p:nvSpPr>
           <p:cNvPr id="2" name="Rectangle 1"/>
@@ -19789,6 +20733,7 @@
           <a:lstStyle/>
           <a:p>
             <a:pPr algn="ctr"/>
+            <a:endParaRPr/>
           </a:p>
         </p:txBody>
       </p:sp>
@@ -19832,6 +20777,7 @@
           <a:lstStyle/>
           <a:p>
             <a:pPr algn="ctr"/>
+            <a:endParaRPr/>
           </a:p>
         </p:txBody>
       </p:sp>
@@ -20032,7 +20978,7 @@
 </file>
 
 <file path=ppt/slides/slide7.xml><?xml version="1.0" encoding="utf-8"?>
-<p:sld xmlns:a="http://schemas.openxmlformats.org/drawingml/2006/main" xmlns:p="http://schemas.openxmlformats.org/presentationml/2006/main" xmlns:r="http://schemas.openxmlformats.org/officeDocument/2006/relationships">
+<p:sld xmlns:a="http://schemas.openxmlformats.org/drawingml/2006/main" xmlns:r="http://schemas.openxmlformats.org/officeDocument/2006/relationships" xmlns:p="http://schemas.openxmlformats.org/presentationml/2006/main">
   <p:cSld>
     <p:spTree>
       <p:nvGrpSpPr>
@@ -20040,7 +20986,14 @@
         <p:cNvGrpSpPr/>
         <p:nvPr/>
       </p:nvGrpSpPr>
-      <p:grpSpPr/>
+      <p:grpSpPr>
+        <a:xfrm>
+          <a:off x="0" y="0"/>
+          <a:ext cx="0" cy="0"/>
+          <a:chOff x="0" y="0"/>
+          <a:chExt cx="0" cy="0"/>
+        </a:xfrm>
+      </p:grpSpPr>
       <p:sp>
         <p:nvSpPr>
           <p:cNvPr id="2" name="Rectangle 1"/>
@@ -20081,6 +21034,7 @@
           <a:lstStyle/>
           <a:p>
             <a:pPr algn="ctr"/>
+            <a:endParaRPr/>
           </a:p>
         </p:txBody>
       </p:sp>
@@ -20124,6 +21078,7 @@
           <a:lstStyle/>
           <a:p>
             <a:pPr algn="ctr"/>
+            <a:endParaRPr/>
           </a:p>
         </p:txBody>
       </p:sp>
@@ -20324,7 +21279,7 @@
 </file>
 
 <file path=ppt/slides/slide8.xml><?xml version="1.0" encoding="utf-8"?>
-<p:sld xmlns:a="http://schemas.openxmlformats.org/drawingml/2006/main" xmlns:p="http://schemas.openxmlformats.org/presentationml/2006/main" xmlns:r="http://schemas.openxmlformats.org/officeDocument/2006/relationships">
+<p:sld xmlns:a="http://schemas.openxmlformats.org/drawingml/2006/main" xmlns:r="http://schemas.openxmlformats.org/officeDocument/2006/relationships" xmlns:p="http://schemas.openxmlformats.org/presentationml/2006/main">
   <p:cSld>
     <p:spTree>
       <p:nvGrpSpPr>
@@ -20332,7 +21287,14 @@
         <p:cNvGrpSpPr/>
         <p:nvPr/>
       </p:nvGrpSpPr>
-      <p:grpSpPr/>
+      <p:grpSpPr>
+        <a:xfrm>
+          <a:off x="0" y="0"/>
+          <a:ext cx="0" cy="0"/>
+          <a:chOff x="0" y="0"/>
+          <a:chExt cx="0" cy="0"/>
+        </a:xfrm>
+      </p:grpSpPr>
       <p:sp>
         <p:nvSpPr>
           <p:cNvPr id="2" name="Rectangle 1"/>
@@ -20373,6 +21335,7 @@
           <a:lstStyle/>
           <a:p>
             <a:pPr algn="ctr"/>
+            <a:endParaRPr/>
           </a:p>
         </p:txBody>
       </p:sp>
@@ -20416,6 +21379,7 @@
           <a:lstStyle/>
           <a:p>
             <a:pPr algn="ctr"/>
+            <a:endParaRPr/>
           </a:p>
         </p:txBody>
       </p:sp>
@@ -20616,7 +21580,7 @@
 </file>
 
 <file path=ppt/slides/slide9.xml><?xml version="1.0" encoding="utf-8"?>
-<p:sld xmlns:a="http://schemas.openxmlformats.org/drawingml/2006/main" xmlns:p="http://schemas.openxmlformats.org/presentationml/2006/main" xmlns:r="http://schemas.openxmlformats.org/officeDocument/2006/relationships">
+<p:sld xmlns:a="http://schemas.openxmlformats.org/drawingml/2006/main" xmlns:r="http://schemas.openxmlformats.org/officeDocument/2006/relationships" xmlns:p="http://schemas.openxmlformats.org/presentationml/2006/main">
   <p:cSld>
     <p:spTree>
       <p:nvGrpSpPr>
@@ -20624,7 +21588,14 @@
         <p:cNvGrpSpPr/>
         <p:nvPr/>
       </p:nvGrpSpPr>
-      <p:grpSpPr/>
+      <p:grpSpPr>
+        <a:xfrm>
+          <a:off x="0" y="0"/>
+          <a:ext cx="0" cy="0"/>
+          <a:chOff x="0" y="0"/>
+          <a:chExt cx="0" cy="0"/>
+        </a:xfrm>
+      </p:grpSpPr>
       <p:sp>
         <p:nvSpPr>
           <p:cNvPr id="2" name="Rectangle 1"/>
@@ -20665,6 +21636,7 @@
           <a:lstStyle/>
           <a:p>
             <a:pPr algn="ctr"/>
+            <a:endParaRPr/>
           </a:p>
         </p:txBody>
       </p:sp>
@@ -20708,6 +21680,7 @@
           <a:lstStyle/>
           <a:p>
             <a:pPr algn="ctr"/>
+            <a:endParaRPr/>
           </a:p>
         </p:txBody>
       </p:sp>

</xml_diff>